<commit_message>
feat: sharpen job redesign business pitch
</commit_message>
<xml_diff>
--- a/presentation/Dr-Alfred-Work-Redesign-for-Managing-AI-Agents.pptx
+++ b/presentation/Dr-Alfred-Work-Redesign-for-Managing-AI-Agents.pptx
@@ -512,7 +512,7 @@
             <a:r>
               <a:rPr lang="en-US" dirty="0"/>
               <a:t>Timing: 0:00-0:35
-Open with the premise: the newest team member is software. The leadership question is no longer whether people will use AI, but how work, decision rights and accountability must change when AI can act.</a:t>
+Open with the business tension: AI agents are moving into workflows faster than organisations are redesigning roles. The advantage will not come from deploying the most agents. It will come from giving people clearer ownership, stronger judgement and safer ways to work with them.</a:t>
             </a:r>
             <a:endParaRPr lang="en-US" dirty="0"/>
           </a:p>
@@ -601,7 +601,7 @@
             <a:r>
               <a:rPr lang="en-US" dirty="0"/>
               <a:t>Timing: 8:35-10:00
-Close with three actions: map the work, set human accountability, and coach one person through a small experiment. The headline is the takeaway: do not deploy agents into yesterday's jobs. End on the question: if an AI agent joined your team tomorrow, who would coach the human?</a:t>
+Make the ask concrete: pilot one role for two weeks. Map the work, name the accountable human owner, and coach one person through a bounded experiment with stop rules. Measure cycle time, quality, exception handling, ownership clarity and staff confidence. End with the challenge: do not deploy agents into yesterday's jobs.</a:t>
             </a:r>
             <a:endParaRPr lang="en-US" dirty="0"/>
           </a:p>
@@ -779,7 +779,7 @@
             <a:r>
               <a:rPr lang="en-US" dirty="0"/>
               <a:t>Timing: 1:25-2:25
-WEF does not say every job becomes an agent manager. It says 86 percent of employers expect AI transformation, 77 percent plan to upskill, while 41 percent also anticipate reductions. My practitioner thesis is that directing, checking and governing agents will be added to many existing jobs. That transition has to be designed.</a:t>
+WEF does not say every job becomes an agent manager. It says 86 percent of employers expect AI transformation, 77 percent plan to upskill, while 41 percent also anticipate reductions. The opportunity is to add agent direction, checking and governance to existing roles before ambiguity turns into resistance or risk.</a:t>
             </a:r>
             <a:endParaRPr lang="en-US" dirty="0"/>
           </a:p>
@@ -868,7 +868,7 @@
             <a:r>
               <a:rPr lang="en-US" dirty="0"/>
               <a:t>Timing: 2:25-3:15
-In our own company, agents help with websites and software. We also support clients using agents in their software workflows. The reliable pattern is not hands-off automation. It is human framing, agent execution, human challenge and named approval.</a:t>
+This is our operating model. Agents already contribute to websites and software, and we help clients use them in similar workflows. The repeatable pattern is not hands-off automation. It is human framing, agent execution, human challenge and named approval.</a:t>
             </a:r>
             <a:endParaRPr lang="en-US" dirty="0"/>
           </a:p>
@@ -957,7 +957,7 @@
             <a:r>
               <a:rPr lang="en-US" dirty="0"/>
               <a:t>Timing: 3:15-4:10
-Our implementation tension is staff resistance. If we answer fear with a product demo or say "just upskill", we make it worse. The objection may be about accuracy, but the deeper questions are: am I still valued, what do I own, can I stop the system, and will I be blamed?</a:t>
+The hidden cost is adoption debt when roles lag behind deployment. If we answer fear with a product demo or say "just upskill", we make it worse. The objection may sound technical, but the deeper questions are: am I still valued, what do I own, can I stop the system, and will I be blamed? Treat resistance as design input.</a:t>
             </a:r>
             <a:endParaRPr lang="en-US" dirty="0"/>
           </a:p>
@@ -1046,7 +1046,7 @@
             <a:r>
               <a:rPr lang="en-US" dirty="0"/>
               <a:t>Timing: 4:10-5:10
-The redesigned role is not "watch the machine". It has explicit authority. The human sets intent, challenges evidence, approves consequential actions, handles exceptions and improves the workflow. This makes accountability visible and gives the employee a more meaningful role.</a:t>
+Our solution is a Human Owner role, not a vague instruction to supervise AI. The person sets intent, challenges evidence, approves consequential actions, handles exceptions and improves the workflow. That is a clear job proposition: higher-value judgement with visible authority.</a:t>
             </a:r>
             <a:endParaRPr lang="en-US" dirty="0"/>
           </a:p>
@@ -1135,7 +1135,7 @@
             <a:r>
               <a:rPr lang="en-US" dirty="0"/>
               <a:t>Timing: 5:10-6:10
-We created a simulator around GROW. The coaching move is to validate the emotion, explore reality and strengths, co-create a specific role, and finish with a safe experiment. Empathy is not decoration. It is what allows a threatened employee to engage with the redesign.</a:t>
+The intervention is a structured redesign conversation. Validate the emotion, explore reality and strengths, co-create specific decision rights, and finish with a safe experiment. Empathy is how we obtain honest design input from the person closest to the work.</a:t>
             </a:r>
             <a:endParaRPr lang="en-US" dirty="0"/>
           </a:p>
@@ -1224,7 +1224,7 @@
             <a:r>
               <a:rPr lang="en-US" dirty="0"/>
               <a:t>Timing: 6:10-7:20
-Show the six scenarios. They span fear, anger, anxiety, scepticism, accountability and ethical purpose. Demo one exchange: choose a person, respond as manager, and show how the staff member opens up only after empathy and a concrete redesign. The no-key demo mode makes this reliable in a workshop.</a:t>
+This is the practical product: six scenarios spanning fear, anger, anxiety, scepticism, accountability and ethical purpose. Demo one exchange and show that the staff member opens up when the manager combines empathy with concrete ownership. No-key mode makes the practice reliable in workshops.</a:t>
             </a:r>
             <a:endParaRPr lang="en-US" dirty="0"/>
           </a:p>
@@ -1313,7 +1313,7 @@
             <a:r>
               <a:rPr lang="en-US" dirty="0"/>
               <a:t>Timing: 7:20-8:35
-Sarah begins with the identity question: what do you still need me for? The turning point is not saying AI cannot replace her. It is acknowledging the rushed rollout, drawing out her market strengths and co-creating a role where she directs, challenges and approves the agent.</a:t>
+Sarah begins with the identity question: what do you still need me for? The turning point is not reassurance. It is acknowledging the rushed rollout, drawing out her market strengths and co-creating a more valuable role where she directs, challenges and approves the agent.</a:t>
             </a:r>
             <a:endParaRPr lang="en-US" dirty="0"/>
           </a:p>
@@ -1719,7 +1719,7 @@
                 <a:ea typeface="Arial" pitchFamily="34" charset="-122"/>
                 <a:cs typeface="Arial" pitchFamily="34" charset="-120"/>
               </a:rPr>
-              <a:t>COP@MAKERSPACE - PRACTITIONER SHARING</a:t>
+              <a:t>WORK REDESIGN FOR MANAGING AI AGENTS</a:t>
             </a:r>
             <a:endParaRPr lang="en-US" sz="900" dirty="0"/>
           </a:p>
@@ -1772,44 +1772,8 @@
         </p:nvSpPr>
         <p:spPr>
           <a:xfrm>
-            <a:off x="621792" y="1051560"/>
-            <a:ext cx="5303520" cy="411480"/>
-          </a:xfrm>
-          <a:prstGeom prst="rect">
-            <a:avLst/>
-          </a:prstGeom>
-          <a:noFill/>
-          <a:ln/>
-        </p:spPr>
-        <p:txBody>
-          <a:bodyPr wrap="square" lIns="0" tIns="0" rIns="0" bIns="0" rtlCol="0" anchor="ctr"/>
-          <a:lstStyle/>
-          <a:p>
-            <a:pPr indent="0" marL="0">
-              <a:buNone/>
-            </a:pPr>
-            <a:r>
-              <a:rPr lang="en-US" sz="1800" b="1" spc="280" kern="0" dirty="0">
-                <a:solidFill>
-                  <a:srgbClr val="55D6BE"/>
-                </a:solidFill>
-              </a:rPr>
-              <a:t>WORK REDESIGN FOR</a:t>
-            </a:r>
-            <a:endParaRPr lang="en-US" sz="1800" dirty="0"/>
-          </a:p>
-        </p:txBody>
-      </p:sp>
-      <p:sp>
-        <p:nvSpPr>
-          <p:cNvPr id="5" name="Text 3"/>
-          <p:cNvSpPr/>
-          <p:nvPr/>
-        </p:nvSpPr>
-        <p:spPr>
-          <a:xfrm>
-            <a:off x="594360" y="1508760"/>
-            <a:ext cx="6035040" cy="1920240"/>
+            <a:off x="594360" y="1298448"/>
+            <a:ext cx="6309360" cy="1691640"/>
           </a:xfrm>
           <a:prstGeom prst="rect">
             <a:avLst/>
@@ -1827,77 +1791,41 @@
               <a:buNone/>
             </a:pPr>
             <a:r>
-              <a:rPr lang="en-US" sz="5000" b="1" dirty="0">
+              <a:rPr lang="en-US" sz="3300" b="1" dirty="0">
                 <a:solidFill>
                   <a:srgbClr val="FFFFFF"/>
                 </a:solidFill>
               </a:rPr>
-              <a:t>Managing</a:t>
-            </a:r>
-            <a:endParaRPr lang="en-US" sz="5000" dirty="0"/>
+              <a:t>AI agents move fast.</a:t>
+            </a:r>
+            <a:endParaRPr lang="en-US" sz="3300" dirty="0"/>
           </a:p>
           <a:p>
             <a:pPr indent="0" marL="0">
               <a:buNone/>
             </a:pPr>
             <a:r>
-              <a:rPr lang="en-US" sz="5000" b="1" dirty="0">
+              <a:rPr lang="en-US" sz="3300" b="1" dirty="0">
                 <a:solidFill>
                   <a:srgbClr val="FFFFFF"/>
                 </a:solidFill>
               </a:rPr>
-              <a:t>AI Agents</a:t>
-            </a:r>
-            <a:endParaRPr lang="en-US" sz="5000" dirty="0"/>
-          </a:p>
-        </p:txBody>
-      </p:sp>
-      <p:sp>
-        <p:nvSpPr>
-          <p:cNvPr id="6" name="Text 4"/>
-          <p:cNvSpPr/>
-          <p:nvPr/>
-        </p:nvSpPr>
-        <p:spPr>
-          <a:xfrm>
-            <a:off x="621792" y="3657600"/>
-            <a:ext cx="5394960" cy="384048"/>
-          </a:xfrm>
-          <a:prstGeom prst="rect">
-            <a:avLst/>
-          </a:prstGeom>
-          <a:noFill/>
-          <a:ln/>
-        </p:spPr>
-        <p:txBody>
-          <a:bodyPr wrap="square" lIns="0" tIns="0" rIns="0" bIns="0" rtlCol="0" anchor="ctr"/>
-          <a:lstStyle/>
-          <a:p>
-            <a:pPr indent="0" marL="0">
-              <a:buNone/>
-            </a:pPr>
-            <a:r>
-              <a:rPr lang="en-US" sz="2000" dirty="0">
-                <a:solidFill>
-                  <a:srgbClr val="D8EDF1"/>
-                </a:solidFill>
-              </a:rPr>
-              <a:t>From AI assistant to digital co-worker</a:t>
-            </a:r>
-            <a:endParaRPr lang="en-US" sz="2000" dirty="0"/>
-          </a:p>
-        </p:txBody>
-      </p:sp>
-      <p:sp>
-        <p:nvSpPr>
-          <p:cNvPr id="7" name="Text 5"/>
-          <p:cNvSpPr/>
-          <p:nvPr/>
-        </p:nvSpPr>
-        <p:spPr>
-          <a:xfrm>
-            <a:off x="621792" y="4828032"/>
-            <a:ext cx="5394960" cy="685800"/>
+              <a:t>Work design must catch up.</a:t>
+            </a:r>
+            <a:endParaRPr lang="en-US" sz="3300" dirty="0"/>
+          </a:p>
+        </p:txBody>
+      </p:sp>
+      <p:sp>
+        <p:nvSpPr>
+          <p:cNvPr id="5" name="Text 3"/>
+          <p:cNvSpPr/>
+          <p:nvPr/>
+        </p:nvSpPr>
+        <p:spPr>
+          <a:xfrm>
+            <a:off x="621792" y="3310128"/>
+            <a:ext cx="5440680" cy="749808"/>
           </a:xfrm>
           <a:prstGeom prst="rect">
             <a:avLst/>
@@ -1915,6 +1843,58 @@
               <a:buNone/>
             </a:pPr>
             <a:r>
+              <a:rPr lang="en-US" sz="2000" b="1" dirty="0">
+                <a:solidFill>
+                  <a:srgbClr val="D8EDF1"/>
+                </a:solidFill>
+              </a:rPr>
+              <a:t>The competitive advantage is not more agents.</a:t>
+            </a:r>
+            <a:endParaRPr lang="en-US" sz="2000" dirty="0"/>
+          </a:p>
+          <a:p>
+            <a:pPr indent="0" marL="0">
+              <a:buNone/>
+            </a:pPr>
+            <a:r>
+              <a:rPr lang="en-US" sz="2000" b="1" dirty="0">
+                <a:solidFill>
+                  <a:srgbClr val="D8EDF1"/>
+                </a:solidFill>
+              </a:rPr>
+              <a:t>It is better human ownership.</a:t>
+            </a:r>
+            <a:endParaRPr lang="en-US" sz="2000" dirty="0"/>
+          </a:p>
+        </p:txBody>
+      </p:sp>
+      <p:sp>
+        <p:nvSpPr>
+          <p:cNvPr id="6" name="Text 4"/>
+          <p:cNvSpPr/>
+          <p:nvPr/>
+        </p:nvSpPr>
+        <p:spPr>
+          <a:xfrm>
+            <a:off x="621792" y="4828032"/>
+            <a:ext cx="5394960" cy="685800"/>
+          </a:xfrm>
+          <a:prstGeom prst="rect">
+            <a:avLst/>
+          </a:prstGeom>
+          <a:noFill/>
+          <a:ln/>
+        </p:spPr>
+        <p:txBody>
+          <a:bodyPr wrap="square" lIns="0" tIns="0" rIns="0" bIns="0" rtlCol="0" anchor="ctr">
+            <a:normAutofit/>
+          </a:bodyPr>
+          <a:lstStyle/>
+          <a:p>
+            <a:pPr indent="0" marL="0">
+              <a:buNone/>
+            </a:pPr>
+            <a:r>
               <a:rPr lang="en-US" sz="1450" dirty="0">
                 <a:solidFill>
                   <a:srgbClr val="B9D7DE"/>
@@ -1942,7 +1922,7 @@
       </p:sp>
       <p:sp>
         <p:nvSpPr>
-          <p:cNvPr id="8" name="Shape 6"/>
+          <p:cNvPr id="7" name="Shape 5"/>
           <p:cNvSpPr/>
           <p:nvPr/>
         </p:nvSpPr>
@@ -1969,7 +1949,7 @@
       </p:sp>
       <p:sp>
         <p:nvSpPr>
-          <p:cNvPr id="9" name="Shape 7"/>
+          <p:cNvPr id="8" name="Shape 6"/>
           <p:cNvSpPr/>
           <p:nvPr/>
         </p:nvSpPr>
@@ -1994,7 +1974,7 @@
       </p:sp>
       <p:sp>
         <p:nvSpPr>
-          <p:cNvPr id="10" name="Text 8"/>
+          <p:cNvPr id="9" name="Text 7"/>
           <p:cNvSpPr/>
           <p:nvPr/>
         </p:nvSpPr>
@@ -2035,7 +2015,7 @@
       </p:sp>
       <p:sp>
         <p:nvSpPr>
-          <p:cNvPr id="11" name="Shape 9"/>
+          <p:cNvPr id="10" name="Shape 8"/>
           <p:cNvSpPr/>
           <p:nvPr/>
         </p:nvSpPr>
@@ -2062,7 +2042,7 @@
       </p:sp>
       <p:sp>
         <p:nvSpPr>
-          <p:cNvPr id="12" name="Shape 10"/>
+          <p:cNvPr id="11" name="Shape 9"/>
           <p:cNvSpPr/>
           <p:nvPr/>
         </p:nvSpPr>
@@ -2087,7 +2067,7 @@
       </p:sp>
       <p:sp>
         <p:nvSpPr>
-          <p:cNvPr id="13" name="Text 11"/>
+          <p:cNvPr id="12" name="Text 10"/>
           <p:cNvSpPr/>
           <p:nvPr/>
         </p:nvSpPr>
@@ -2128,7 +2108,7 @@
       </p:sp>
       <p:sp>
         <p:nvSpPr>
-          <p:cNvPr id="14" name="Shape 12"/>
+          <p:cNvPr id="13" name="Shape 11"/>
           <p:cNvSpPr/>
           <p:nvPr/>
         </p:nvSpPr>
@@ -2155,7 +2135,7 @@
       </p:sp>
       <p:sp>
         <p:nvSpPr>
-          <p:cNvPr id="15" name="Shape 13"/>
+          <p:cNvPr id="14" name="Shape 12"/>
           <p:cNvSpPr/>
           <p:nvPr/>
         </p:nvSpPr>
@@ -2180,7 +2160,7 @@
       </p:sp>
       <p:sp>
         <p:nvSpPr>
-          <p:cNvPr id="16" name="Text 14"/>
+          <p:cNvPr id="15" name="Text 13"/>
           <p:cNvSpPr/>
           <p:nvPr/>
         </p:nvSpPr>
@@ -2221,7 +2201,7 @@
       </p:sp>
       <p:sp>
         <p:nvSpPr>
-          <p:cNvPr id="17" name="Shape 15"/>
+          <p:cNvPr id="16" name="Shape 14"/>
           <p:cNvSpPr/>
           <p:nvPr/>
         </p:nvSpPr>
@@ -2248,7 +2228,7 @@
       </p:sp>
       <p:sp>
         <p:nvSpPr>
-          <p:cNvPr id="18" name="Shape 16"/>
+          <p:cNvPr id="17" name="Shape 15"/>
           <p:cNvSpPr/>
           <p:nvPr/>
         </p:nvSpPr>
@@ -2273,7 +2253,7 @@
       </p:sp>
       <p:sp>
         <p:nvSpPr>
-          <p:cNvPr id="19" name="Text 17"/>
+          <p:cNvPr id="18" name="Text 16"/>
           <p:cNvSpPr/>
           <p:nvPr/>
         </p:nvSpPr>
@@ -2314,7 +2294,7 @@
       </p:sp>
       <p:sp>
         <p:nvSpPr>
-          <p:cNvPr id="20" name="Shape 18"/>
+          <p:cNvPr id="19" name="Shape 17"/>
           <p:cNvSpPr/>
           <p:nvPr/>
         </p:nvSpPr>
@@ -2341,7 +2321,7 @@
       </p:sp>
       <p:sp>
         <p:nvSpPr>
-          <p:cNvPr id="21" name="Shape 19"/>
+          <p:cNvPr id="20" name="Shape 18"/>
           <p:cNvSpPr/>
           <p:nvPr/>
         </p:nvSpPr>
@@ -2366,7 +2346,7 @@
       </p:sp>
       <p:sp>
         <p:nvSpPr>
-          <p:cNvPr id="22" name="Text 20"/>
+          <p:cNvPr id="21" name="Text 19"/>
           <p:cNvSpPr/>
           <p:nvPr/>
         </p:nvSpPr>
@@ -2407,7 +2387,7 @@
       </p:sp>
       <p:sp>
         <p:nvSpPr>
-          <p:cNvPr id="23" name="Shape 21"/>
+          <p:cNvPr id="22" name="Shape 20"/>
           <p:cNvSpPr/>
           <p:nvPr/>
         </p:nvSpPr>
@@ -2434,7 +2414,7 @@
       </p:sp>
       <p:sp>
         <p:nvSpPr>
-          <p:cNvPr id="24" name="Shape 22"/>
+          <p:cNvPr id="23" name="Shape 21"/>
           <p:cNvSpPr/>
           <p:nvPr/>
         </p:nvSpPr>
@@ -2459,7 +2439,7 @@
       </p:sp>
       <p:sp>
         <p:nvSpPr>
-          <p:cNvPr id="25" name="Text 23"/>
+          <p:cNvPr id="24" name="Text 22"/>
           <p:cNvSpPr/>
           <p:nvPr/>
         </p:nvSpPr>
@@ -2500,7 +2480,7 @@
       </p:sp>
       <p:sp>
         <p:nvSpPr>
-          <p:cNvPr id="26" name="Shape 24"/>
+          <p:cNvPr id="25" name="Shape 23"/>
           <p:cNvSpPr/>
           <p:nvPr/>
         </p:nvSpPr>
@@ -2527,7 +2507,7 @@
       </p:sp>
       <p:sp>
         <p:nvSpPr>
-          <p:cNvPr id="27" name="Shape 25"/>
+          <p:cNvPr id="26" name="Shape 24"/>
           <p:cNvSpPr/>
           <p:nvPr/>
         </p:nvSpPr>
@@ -2552,7 +2532,7 @@
       </p:sp>
       <p:sp>
         <p:nvSpPr>
-          <p:cNvPr id="28" name="Text 26"/>
+          <p:cNvPr id="27" name="Text 25"/>
           <p:cNvSpPr/>
           <p:nvPr/>
         </p:nvSpPr>
@@ -2593,7 +2573,7 @@
       </p:sp>
       <p:sp>
         <p:nvSpPr>
-          <p:cNvPr id="29" name="Shape 27"/>
+          <p:cNvPr id="28" name="Shape 26"/>
           <p:cNvSpPr/>
           <p:nvPr/>
         </p:nvSpPr>
@@ -2620,7 +2600,7 @@
       </p:sp>
       <p:sp>
         <p:nvSpPr>
-          <p:cNvPr id="30" name="Shape 28"/>
+          <p:cNvPr id="29" name="Shape 27"/>
           <p:cNvSpPr/>
           <p:nvPr/>
         </p:nvSpPr>
@@ -2645,7 +2625,7 @@
       </p:sp>
       <p:sp>
         <p:nvSpPr>
-          <p:cNvPr id="31" name="Text 29"/>
+          <p:cNvPr id="30" name="Text 28"/>
           <p:cNvSpPr/>
           <p:nvPr/>
         </p:nvSpPr>
@@ -2686,7 +2666,7 @@
       </p:sp>
       <p:sp>
         <p:nvSpPr>
-          <p:cNvPr id="32" name="Shape 30"/>
+          <p:cNvPr id="31" name="Shape 29"/>
           <p:cNvSpPr/>
           <p:nvPr/>
         </p:nvSpPr>
@@ -2711,7 +2691,7 @@
       </p:sp>
       <p:sp>
         <p:nvSpPr>
-          <p:cNvPr id="33" name="Text 31"/>
+          <p:cNvPr id="32" name="Text 30"/>
           <p:cNvSpPr/>
           <p:nvPr/>
         </p:nvSpPr>
@@ -2763,7 +2743,7 @@
       </p:sp>
       <p:sp>
         <p:nvSpPr>
-          <p:cNvPr id="34" name="Text 32"/>
+          <p:cNvPr id="33" name="Text 31"/>
           <p:cNvSpPr/>
           <p:nvPr/>
         </p:nvSpPr>
@@ -2791,7 +2771,7 @@
                   <a:srgbClr val="55D6BE"/>
                 </a:solidFill>
               </a:rPr>
-              <a:t>SCOPE  &gt;  CHALLENGE  &gt;  DECIDE</a:t>
+              <a:t>REDESIGN  &gt;  REHEARSE  &gt;  RELEASE</a:t>
             </a:r>
             <a:endParaRPr lang="en-US" sz="1100" dirty="0"/>
           </a:p>
@@ -2799,13 +2779,13 @@
       </p:sp>
       <p:sp>
         <p:nvSpPr>
-          <p:cNvPr id="35" name="Text 33"/>
-          <p:cNvSpPr/>
-          <p:nvPr/>
-        </p:nvSpPr>
-        <p:spPr>
-          <a:xfrm>
-            <a:off x="9464040" y="6446520"/>
+          <p:cNvPr id="34" name="Text 32"/>
+          <p:cNvSpPr/>
+          <p:nvPr/>
+        </p:nvSpPr>
+        <p:spPr>
+          <a:xfrm>
+            <a:off x="9464040" y="6373368"/>
             <a:ext cx="2176272" cy="201168"/>
           </a:xfrm>
           <a:prstGeom prst="rect">
@@ -2901,7 +2881,7 @@
                 <a:ea typeface="Arial" pitchFamily="34" charset="-122"/>
                 <a:cs typeface="Arial" pitchFamily="34" charset="-120"/>
               </a:rPr>
-              <a:t>THE CALL TO ACTION</a:t>
+              <a:t>THE ASK</a:t>
             </a:r>
             <a:endParaRPr lang="en-US" sz="900" dirty="0"/>
           </a:p>
@@ -2973,28 +2953,28 @@
               <a:buNone/>
             </a:pPr>
             <a:r>
-              <a:rPr lang="en-US" sz="3900" b="1" dirty="0">
+              <a:rPr lang="en-US" sz="4400" b="1" dirty="0">
                 <a:solidFill>
                   <a:srgbClr val="FFFFFF"/>
                 </a:solidFill>
               </a:rPr>
-              <a:t>DO NOT DEPLOY AGENTS</a:t>
-            </a:r>
-            <a:endParaRPr lang="en-US" sz="3900" dirty="0"/>
+              <a:t>PILOT ONE ROLE</a:t>
+            </a:r>
+            <a:endParaRPr lang="en-US" sz="4400" dirty="0"/>
           </a:p>
           <a:p>
             <a:pPr indent="0" marL="0">
               <a:buNone/>
             </a:pPr>
             <a:r>
-              <a:rPr lang="en-US" sz="3900" b="1" dirty="0">
+              <a:rPr lang="en-US" sz="4400" b="1" dirty="0">
                 <a:solidFill>
                   <a:srgbClr val="FFFFFF"/>
                 </a:solidFill>
               </a:rPr>
-              <a:t>INTO YESTERDAY'S JOBS.</a:t>
-            </a:r>
-            <a:endParaRPr lang="en-US" sz="3900" dirty="0"/>
+              <a:t>FOR TWO WEEKS.</a:t>
+            </a:r>
+            <a:endParaRPr lang="en-US" sz="4400" dirty="0"/>
           </a:p>
         </p:txBody>
       </p:sp>
@@ -3028,7 +3008,7 @@
                   <a:srgbClr val="C7E3E7"/>
                 </a:solidFill>
               </a:rPr>
-              <a:t>Redesign the work. Name the human owner. Coach the transition.</a:t>
+              <a:t>Small scope. Named owner. Safe stop rules. Measurable evidence.</a:t>
             </a:r>
             <a:endParaRPr lang="en-US" sz="2200" dirty="0"/>
           </a:p>
@@ -3599,7 +3579,83 @@
       </p:sp>
       <p:sp>
         <p:nvSpPr>
-          <p:cNvPr id="23" name="Text 20">
+          <p:cNvPr id="23" name="Text 20"/>
+          <p:cNvSpPr/>
+          <p:nvPr/>
+        </p:nvSpPr>
+        <p:spPr>
+          <a:xfrm>
+            <a:off x="8887968" y="3730752"/>
+            <a:ext cx="2606040" cy="219456"/>
+          </a:xfrm>
+          <a:prstGeom prst="rect">
+            <a:avLst/>
+          </a:prstGeom>
+          <a:noFill/>
+          <a:ln/>
+        </p:spPr>
+        <p:txBody>
+          <a:bodyPr wrap="square" lIns="0" tIns="0" rIns="0" bIns="0" rtlCol="0" anchor="ctr">
+            <a:normAutofit/>
+          </a:bodyPr>
+          <a:lstStyle/>
+          <a:p>
+            <a:pPr algn="ctr" indent="0" marL="0">
+              <a:buNone/>
+            </a:pPr>
+            <a:r>
+              <a:rPr lang="en-US" sz="950" dirty="0">
+                <a:solidFill>
+                  <a:srgbClr val="FFFFFF"/>
+                </a:solidFill>
+              </a:rPr>
+              <a:t>alfredang.github.io/AICoahcing</a:t>
+            </a:r>
+            <a:endParaRPr lang="en-US" sz="950" dirty="0"/>
+          </a:p>
+        </p:txBody>
+      </p:sp>
+      <p:sp>
+        <p:nvSpPr>
+          <p:cNvPr id="24" name="Text 21"/>
+          <p:cNvSpPr/>
+          <p:nvPr/>
+        </p:nvSpPr>
+        <p:spPr>
+          <a:xfrm>
+            <a:off x="658368" y="5632704"/>
+            <a:ext cx="10378440" cy="438912"/>
+          </a:xfrm>
+          <a:prstGeom prst="rect">
+            <a:avLst/>
+          </a:prstGeom>
+          <a:noFill/>
+          <a:ln/>
+        </p:spPr>
+        <p:txBody>
+          <a:bodyPr wrap="square" lIns="0" tIns="0" rIns="0" bIns="0" rtlCol="0" anchor="ctr">
+            <a:normAutofit/>
+          </a:bodyPr>
+          <a:lstStyle/>
+          <a:p>
+            <a:pPr algn="l" indent="0" marL="0">
+              <a:buNone/>
+            </a:pPr>
+            <a:r>
+              <a:rPr lang="en-US" sz="2000" b="1" dirty="0">
+                <a:solidFill>
+                  <a:srgbClr val="F4B942"/>
+                </a:solidFill>
+              </a:rPr>
+              <a:t>MEASURE: cycle time  |  defect count  |  exception rate  |  role-confidence score</a:t>
+            </a:r>
+            <a:endParaRPr lang="en-US" sz="2000" dirty="0"/>
+          </a:p>
+        </p:txBody>
+      </p:sp>
+      <p:sp>
+        <p:nvSpPr>
+          <p:cNvPr id="25" name="Text 22">
             <a:hlinkClick r:id="rId3" tooltip=""/>
           </p:cNvPr>
           <p:cNvSpPr/>
@@ -3607,27 +3663,32 @@
         </p:nvSpPr>
         <p:spPr>
           <a:xfrm>
-            <a:off x="9162288" y="3639312"/>
-            <a:ext cx="2057400" cy="502920"/>
-          </a:xfrm>
-          <a:prstGeom prst="rect">
-            <a:avLst/>
-          </a:prstGeom>
-          <a:noFill/>
-          <a:ln/>
-        </p:spPr>
-        <p:txBody>
-          <a:bodyPr wrap="square" lIns="0" tIns="0" rIns="0" bIns="0" rtlCol="0" anchor="ctr"/>
-          <a:lstStyle/>
-          <a:p>
-            <a:pPr algn="ctr" indent="0" marL="0">
-              <a:buNone/>
-            </a:pPr>
-            <a:r>
-              <a:rPr lang="en-US" sz="1300" u="sng" dirty="0">
-                <a:solidFill>
-                  <a:srgbClr val="FFFFFF"/>
-                </a:solidFill>
+            <a:off x="658368" y="6355080"/>
+            <a:ext cx="9921240" cy="219456"/>
+          </a:xfrm>
+          <a:prstGeom prst="rect">
+            <a:avLst/>
+          </a:prstGeom>
+          <a:noFill/>
+          <a:ln/>
+        </p:spPr>
+        <p:txBody>
+          <a:bodyPr wrap="square" lIns="0" tIns="0" rIns="0" bIns="0" rtlCol="0" anchor="ctr">
+            <a:normAutofit/>
+          </a:bodyPr>
+          <a:lstStyle/>
+          <a:p>
+            <a:pPr indent="0" marL="0">
+              <a:buNone/>
+            </a:pPr>
+            <a:r>
+              <a:rPr lang="en-US" sz="1000" u="sng" dirty="0">
+                <a:solidFill>
+                  <a:srgbClr val="A7C9D2"/>
+                </a:solidFill>
+                <a:latin typeface="Arial" pitchFamily="34" charset="0"/>
+                <a:ea typeface="Arial" pitchFamily="34" charset="-122"/>
+                <a:cs typeface="Arial" pitchFamily="34" charset="-120"/>
                 <a:hlinkClick r:id="rId3" invalidUrl="" action="" tgtFrame="" tooltip="" history="1" highlightClick="0" endSnd="0">
                   <a:extLst>
                     <a:ext uri="{A12FA001-AC4F-418D-AE19-62706E023703}">
@@ -3636,115 +3697,6 @@
                   </a:extLst>
                 </a:hlinkClick>
               </a:rPr>
-              <a:t>alfredang.github.io/</a:t>
-            </a:r>
-            <a:endParaRPr lang="en-US" sz="1300" dirty="0"/>
-          </a:p>
-          <a:p>
-            <a:pPr algn="ctr" indent="0" marL="0">
-              <a:buNone/>
-            </a:pPr>
-            <a:r>
-              <a:rPr lang="en-US" sz="1300" u="sng" dirty="0">
-                <a:solidFill>
-                  <a:srgbClr val="FFFFFF"/>
-                </a:solidFill>
-                <a:hlinkClick r:id="rId3" invalidUrl="" action="" tgtFrame="" tooltip="" history="1" highlightClick="0" endSnd="0">
-                  <a:extLst>
-                    <a:ext uri="{A12FA001-AC4F-418D-AE19-62706E023703}">
-                      <ahyp:hlinkClr xmlns:ahyp="http://schemas.microsoft.com/office/drawing/2018/hyperlinkcolor" val="tx"/>
-                    </a:ext>
-                  </a:extLst>
-                </a:hlinkClick>
-              </a:rPr>
-              <a:t>AICoahcing</a:t>
-            </a:r>
-            <a:endParaRPr lang="en-US" sz="1300" dirty="0"/>
-          </a:p>
-        </p:txBody>
-      </p:sp>
-      <p:sp>
-        <p:nvSpPr>
-          <p:cNvPr id="24" name="Text 21"/>
-          <p:cNvSpPr/>
-          <p:nvPr/>
-        </p:nvSpPr>
-        <p:spPr>
-          <a:xfrm>
-            <a:off x="658368" y="5705856"/>
-            <a:ext cx="10378440" cy="475488"/>
-          </a:xfrm>
-          <a:prstGeom prst="rect">
-            <a:avLst/>
-          </a:prstGeom>
-          <a:noFill/>
-          <a:ln/>
-        </p:spPr>
-        <p:txBody>
-          <a:bodyPr wrap="square" lIns="0" tIns="0" rIns="0" bIns="0" rtlCol="0" anchor="ctr">
-            <a:normAutofit/>
-          </a:bodyPr>
-          <a:lstStyle/>
-          <a:p>
-            <a:pPr algn="l" indent="0" marL="0">
-              <a:buNone/>
-            </a:pPr>
-            <a:r>
-              <a:rPr lang="en-US" sz="2500" b="1" dirty="0">
-                <a:solidFill>
-                  <a:srgbClr val="F4B942"/>
-                </a:solidFill>
-              </a:rPr>
-              <a:t>If an AI agent joined your team tomorrow, who would coach the human?</a:t>
-            </a:r>
-            <a:endParaRPr lang="en-US" sz="2500" dirty="0"/>
-          </a:p>
-        </p:txBody>
-      </p:sp>
-      <p:sp>
-        <p:nvSpPr>
-          <p:cNvPr id="25" name="Text 22">
-            <a:hlinkClick r:id="rId4" tooltip=""/>
-          </p:cNvPr>
-          <p:cNvSpPr/>
-          <p:nvPr/>
-        </p:nvSpPr>
-        <p:spPr>
-          <a:xfrm>
-            <a:off x="658368" y="6428232"/>
-            <a:ext cx="9921240" cy="219456"/>
-          </a:xfrm>
-          <a:prstGeom prst="rect">
-            <a:avLst/>
-          </a:prstGeom>
-          <a:noFill/>
-          <a:ln/>
-        </p:spPr>
-        <p:txBody>
-          <a:bodyPr wrap="square" lIns="0" tIns="0" rIns="0" bIns="0" rtlCol="0" anchor="ctr">
-            <a:normAutofit/>
-          </a:bodyPr>
-          <a:lstStyle/>
-          <a:p>
-            <a:pPr indent="0" marL="0">
-              <a:buNone/>
-            </a:pPr>
-            <a:r>
-              <a:rPr lang="en-US" sz="1000" u="sng" dirty="0">
-                <a:solidFill>
-                  <a:srgbClr val="A7C9D2"/>
-                </a:solidFill>
-                <a:latin typeface="Arial" pitchFamily="34" charset="0"/>
-                <a:ea typeface="Arial" pitchFamily="34" charset="-122"/>
-                <a:cs typeface="Arial" pitchFamily="34" charset="-120"/>
-                <a:hlinkClick r:id="rId4" invalidUrl="" action="" tgtFrame="" tooltip="" history="1" highlightClick="0" endSnd="0">
-                  <a:extLst>
-                    <a:ext uri="{A12FA001-AC4F-418D-AE19-62706E023703}">
-                      <ahyp:hlinkClr xmlns:ahyp="http://schemas.microsoft.com/office/drawing/2018/hyperlinkcolor" val="tx"/>
-                    </a:ext>
-                  </a:extLst>
-                </a:hlinkClick>
-              </a:rPr>
               <a:t>Simulator and slides: github.com/alfredang/AICoahcing</a:t>
             </a:r>
             <a:endParaRPr lang="en-US" sz="1000" dirty="0"/>
@@ -3759,7 +3711,7 @@
         </p:nvSpPr>
         <p:spPr>
           <a:xfrm>
-            <a:off x="9464040" y="6446520"/>
+            <a:off x="9464040" y="6373368"/>
             <a:ext cx="2176272" cy="201168"/>
           </a:xfrm>
           <a:prstGeom prst="rect">
@@ -3880,7 +3832,7 @@
                 <a:ea typeface="Arial" pitchFamily="34" charset="-122"/>
                 <a:cs typeface="Arial" pitchFamily="34" charset="-120"/>
               </a:rPr>
-              <a:t>THE SIGNAL</a:t>
+              <a:t>WHY NOW</a:t>
             </a:r>
             <a:endParaRPr lang="en-US" sz="900" dirty="0"/>
           </a:p>
@@ -3960,7 +3912,7 @@
                 <a:ea typeface="Arial" pitchFamily="34" charset="-122"/>
                 <a:cs typeface="Arial" pitchFamily="34" charset="-120"/>
               </a:rPr>
-              <a:t>Singapore just made agent management a frontline skill.</a:t>
+              <a:t>12,000+ agents. One lesson: ownership cannot be automated.</a:t>
             </a:r>
             <a:endParaRPr lang="en-US" sz="2900" dirty="0"/>
           </a:p>
@@ -4001,7 +3953,7 @@
                 <a:ea typeface="Arial" pitchFamily="34" charset="-122"/>
                 <a:cs typeface="Arial" pitchFamily="34" charset="-120"/>
               </a:rPr>
-              <a:t>AgentSea shows that non-technical professionals are already building, deploying and managing agents.</a:t>
+              <a:t>AgentSea shows frontline professionals building and managing agents while humans retain consequential decisions.</a:t>
             </a:r>
             <a:endParaRPr lang="en-US" sz="1500" dirty="0"/>
           </a:p>
@@ -4437,7 +4389,7 @@
         </p:nvSpPr>
         <p:spPr>
           <a:xfrm>
-            <a:off x="658368" y="6428232"/>
+            <a:off x="658368" y="6355080"/>
             <a:ext cx="9921240" cy="219456"/>
           </a:xfrm>
           <a:prstGeom prst="rect">
@@ -4485,7 +4437,7 @@
         </p:nvSpPr>
         <p:spPr>
           <a:xfrm>
-            <a:off x="9464040" y="6446520"/>
+            <a:off x="9464040" y="6373368"/>
             <a:ext cx="2176272" cy="201168"/>
           </a:xfrm>
           <a:prstGeom prst="rect">
@@ -4606,7 +4558,7 @@
                 <a:ea typeface="Arial" pitchFamily="34" charset="-122"/>
                 <a:cs typeface="Arial" pitchFamily="34" charset="-120"/>
               </a:rPr>
-              <a:t>THE LABOUR-MARKET SHIFT</a:t>
+              <a:t>THE STAKES</a:t>
             </a:r>
             <a:endParaRPr lang="en-US" sz="900" dirty="0"/>
           </a:p>
@@ -4686,7 +4638,7 @@
                 <a:ea typeface="Arial" pitchFamily="34" charset="-122"/>
                 <a:cs typeface="Arial" pitchFamily="34" charset="-120"/>
               </a:rPr>
-              <a:t>Jobs are changing faster than job titles.</a:t>
+              <a:t>The advantage comes from redesigning work—not merely deploying AI.</a:t>
             </a:r>
             <a:endParaRPr lang="en-US" sz="2900" dirty="0"/>
           </a:p>
@@ -4727,7 +4679,7 @@
                 <a:ea typeface="Arial" pitchFamily="34" charset="-122"/>
                 <a:cs typeface="Arial" pitchFamily="34" charset="-120"/>
               </a:rPr>
-              <a:t>WEF projects both creation and displacement - making the transition a design challenge, not an automatic win.</a:t>
+              <a:t>WEF projects creation and displacement at the same time. The transition must be deliberately designed.</a:t>
             </a:r>
             <a:endParaRPr lang="en-US" sz="1500" dirty="0"/>
           </a:p>
@@ -5502,7 +5454,7 @@
                   <a:srgbClr val="092F57"/>
                 </a:solidFill>
               </a:rPr>
-              <a:t>PRACTITIONER THESIS</a:t>
+              <a:t>THE OPPORTUNITY</a:t>
             </a:r>
             <a:endParaRPr lang="en-US" sz="950" dirty="0"/>
           </a:p>
@@ -5540,7 +5492,7 @@
                   <a:srgbClr val="092F57"/>
                 </a:solidFill>
               </a:rPr>
-              <a:t>Managing AI becomes part of many jobs.</a:t>
+              <a:t>Make agent management part of the job.</a:t>
             </a:r>
             <a:endParaRPr lang="en-US" sz="1600" dirty="0"/>
           </a:p>
@@ -5556,7 +5508,7 @@
         </p:nvSpPr>
         <p:spPr>
           <a:xfrm>
-            <a:off x="658368" y="6428232"/>
+            <a:off x="658368" y="6355080"/>
             <a:ext cx="9921240" cy="219456"/>
           </a:xfrm>
           <a:prstGeom prst="rect">
@@ -5604,7 +5556,7 @@
         </p:nvSpPr>
         <p:spPr>
           <a:xfrm>
-            <a:off x="9464040" y="6446520"/>
+            <a:off x="9464040" y="6373368"/>
             <a:ext cx="2176272" cy="201168"/>
           </a:xfrm>
           <a:prstGeom prst="rect">
@@ -5725,7 +5677,7 @@
                 <a:ea typeface="Arial" pitchFamily="34" charset="-122"/>
                 <a:cs typeface="Arial" pitchFamily="34" charset="-120"/>
               </a:rPr>
-              <a:t>PRACTICE FROM THE FIELD</a:t>
+              <a:t>OUR OPERATING MODEL</a:t>
             </a:r>
             <a:endParaRPr lang="en-US" sz="900" dirty="0"/>
           </a:p>
@@ -5805,7 +5757,7 @@
                 <a:ea typeface="Arial" pitchFamily="34" charset="-122"/>
                 <a:cs typeface="Arial" pitchFamily="34" charset="-120"/>
               </a:rPr>
-              <a:t>At Tertiary, agents already work inside the workflow.</a:t>
+              <a:t>Keep a human accountable at every consequential gate.</a:t>
             </a:r>
             <a:endParaRPr lang="en-US" sz="2900" dirty="0"/>
           </a:p>
@@ -5846,7 +5798,7 @@
                 <a:ea typeface="Arial" pitchFamily="34" charset="-122"/>
                 <a:cs typeface="Arial" pitchFamily="34" charset="-120"/>
               </a:rPr>
-              <a:t>We use agents to manage websites and software - and help clients do the same.</a:t>
+              <a:t>At Tertiary, agents support website and software workflows—and we help clients apply the same pattern.</a:t>
             </a:r>
             <a:endParaRPr lang="en-US" sz="1500" dirty="0"/>
           </a:p>
@@ -5914,7 +5866,7 @@
                 <a:ea typeface="Arial" pitchFamily="34" charset="-122"/>
                 <a:cs typeface="Arial" pitchFamily="34" charset="-120"/>
               </a:rPr>
-              <a:t>OUR PRACTICE</a:t>
+              <a:t>LIVE PRACTICE</a:t>
             </a:r>
             <a:endParaRPr lang="en-US" sz="1000" dirty="0"/>
           </a:p>
@@ -6740,7 +6692,7 @@
         <p:spPr>
           <a:xfrm>
             <a:off x="914400" y="5001768"/>
-            <a:ext cx="1920240" cy="201168"/>
+            <a:ext cx="1234440" cy="201168"/>
           </a:xfrm>
           <a:prstGeom prst="rect">
             <a:avLst/>
@@ -6761,7 +6713,7 @@
                   <a:srgbClr val="55D6BE"/>
                 </a:solidFill>
               </a:rPr>
-              <a:t>THE PRODUCTIVITY GAIN</a:t>
+              <a:t>THE VALUE</a:t>
             </a:r>
             <a:endParaRPr lang="en-US" sz="950" dirty="0"/>
           </a:p>
@@ -6775,8 +6727,8 @@
         </p:nvSpPr>
         <p:spPr>
           <a:xfrm>
-            <a:off x="2880360" y="4937760"/>
-            <a:ext cx="7955280" cy="411480"/>
+            <a:off x="2286000" y="4937760"/>
+            <a:ext cx="8549640" cy="411480"/>
           </a:xfrm>
           <a:prstGeom prst="rect">
             <a:avLst/>
@@ -6799,7 +6751,7 @@
                   <a:srgbClr val="FFFFFF"/>
                 </a:solidFill>
               </a:rPr>
-              <a:t>Agents compress production. Humans move up to direction, judgement and accountability.</a:t>
+              <a:t>Agents increase throughput. Humans protect judgement and accountability.</a:t>
             </a:r>
             <a:endParaRPr lang="en-US" sz="1950" dirty="0"/>
           </a:p>
@@ -6815,7 +6767,7 @@
         </p:nvSpPr>
         <p:spPr>
           <a:xfrm>
-            <a:off x="658368" y="6428232"/>
+            <a:off x="658368" y="6355080"/>
             <a:ext cx="9921240" cy="219456"/>
           </a:xfrm>
           <a:prstGeom prst="rect">
@@ -6863,7 +6815,7 @@
         </p:nvSpPr>
         <p:spPr>
           <a:xfrm>
-            <a:off x="9464040" y="6446520"/>
+            <a:off x="9464040" y="6373368"/>
             <a:ext cx="2176272" cy="201168"/>
           </a:xfrm>
           <a:prstGeom prst="rect">
@@ -6984,7 +6936,7 @@
                 <a:ea typeface="Arial" pitchFamily="34" charset="-122"/>
                 <a:cs typeface="Arial" pitchFamily="34" charset="-120"/>
               </a:rPr>
-              <a:t>THE ADOPTION BOTTLENECK</a:t>
+              <a:t>THE PROBLEM</a:t>
             </a:r>
             <a:endParaRPr lang="en-US" sz="900" dirty="0"/>
           </a:p>
@@ -7064,7 +7016,7 @@
                 <a:ea typeface="Arial" pitchFamily="34" charset="-122"/>
                 <a:cs typeface="Arial" pitchFamily="34" charset="-120"/>
               </a:rPr>
-              <a:t>The real barrier is a threatened work identity.</a:t>
+              <a:t>AI deployment creates adoption debt when roles lag behind.</a:t>
             </a:r>
             <a:endParaRPr lang="en-US" sz="2900" dirty="0"/>
           </a:p>
@@ -7105,7 +7057,7 @@
                 <a:ea typeface="Arial" pitchFamily="34" charset="-122"/>
                 <a:cs typeface="Arial" pitchFamily="34" charset="-120"/>
               </a:rPr>
-              <a:t>Resistance often sounds technical, but underneath it are fear, fairness, control and accountability.</a:t>
+              <a:t>If identity, decision rights and accountability remain unresolved, resistance compounds.</a:t>
             </a:r>
             <a:endParaRPr lang="en-US" sz="1500" dirty="0"/>
           </a:p>
@@ -7856,7 +7808,7 @@
                   <a:srgbClr val="092F57"/>
                 </a:solidFill>
               </a:rPr>
-              <a:t>Technology deployment can be fast. Role transition is human.</a:t>
+              <a:t>Resistance is not a people problem. It is a role-design signal.</a:t>
             </a:r>
             <a:endParaRPr lang="en-US" sz="2300" dirty="0"/>
           </a:p>
@@ -7872,7 +7824,7 @@
         </p:nvSpPr>
         <p:spPr>
           <a:xfrm>
-            <a:off x="658368" y="6428232"/>
+            <a:off x="658368" y="6355080"/>
             <a:ext cx="9921240" cy="219456"/>
           </a:xfrm>
           <a:prstGeom prst="rect">
@@ -7920,7 +7872,7 @@
         </p:nvSpPr>
         <p:spPr>
           <a:xfrm>
-            <a:off x="9464040" y="6446520"/>
+            <a:off x="9464040" y="6373368"/>
             <a:ext cx="2176272" cy="201168"/>
           </a:xfrm>
           <a:prstGeom prst="rect">
@@ -8041,7 +7993,7 @@
                 <a:ea typeface="Arial" pitchFamily="34" charset="-122"/>
                 <a:cs typeface="Arial" pitchFamily="34" charset="-120"/>
               </a:rPr>
-              <a:t>THE REDESIGN</a:t>
+              <a:t>THE SOLUTION</a:t>
             </a:r>
             <a:endParaRPr lang="en-US" sz="900" dirty="0"/>
           </a:p>
@@ -8121,7 +8073,7 @@
                 <a:ea typeface="Arial" pitchFamily="34" charset="-122"/>
                 <a:cs typeface="Arial" pitchFamily="34" charset="-120"/>
               </a:rPr>
-              <a:t>Shift the role: from doing every task to managing a system of work.</a:t>
+              <a:t>The solution is an explicit Human Owner role.</a:t>
             </a:r>
             <a:endParaRPr lang="en-US" sz="2900" dirty="0"/>
           </a:p>
@@ -8162,7 +8114,7 @@
                 <a:ea typeface="Arial" pitchFamily="34" charset="-122"/>
                 <a:cs typeface="Arial" pitchFamily="34" charset="-120"/>
               </a:rPr>
-              <a:t>The agent takes production loops. The human gains decision rights, exception work and accountability.</a:t>
+              <a:t>Move routine production to the agent and make human decision rights visible.</a:t>
             </a:r>
             <a:endParaRPr lang="en-US" sz="1500" dirty="0"/>
           </a:p>
@@ -9130,7 +9082,7 @@
         </p:nvSpPr>
         <p:spPr>
           <a:xfrm>
-            <a:off x="658368" y="6428232"/>
+            <a:off x="658368" y="6355080"/>
             <a:ext cx="9921240" cy="219456"/>
           </a:xfrm>
           <a:prstGeom prst="rect">
@@ -9178,7 +9130,7 @@
         </p:nvSpPr>
         <p:spPr>
           <a:xfrm>
-            <a:off x="9464040" y="6446520"/>
+            <a:off x="9464040" y="6373368"/>
             <a:ext cx="2176272" cy="201168"/>
           </a:xfrm>
           <a:prstGeom prst="rect">
@@ -9299,7 +9251,7 @@
                 <a:ea typeface="Arial" pitchFamily="34" charset="-122"/>
                 <a:cs typeface="Arial" pitchFamily="34" charset="-120"/>
               </a:rPr>
-              <a:t>THE COACHING METHOD</a:t>
+              <a:t>THE INTERVENTION</a:t>
             </a:r>
             <a:endParaRPr lang="en-US" sz="900" dirty="0"/>
           </a:p>
@@ -9379,7 +9331,7 @@
                 <a:ea typeface="Arial" pitchFamily="34" charset="-122"/>
                 <a:cs typeface="Arial" pitchFamily="34" charset="-120"/>
               </a:rPr>
-              <a:t>Coach the transition with GROW.</a:t>
+              <a:t>Turn resistance into a redesign conversation.</a:t>
             </a:r>
             <a:endParaRPr lang="en-US" sz="2900" dirty="0"/>
           </a:p>
@@ -9420,7 +9372,7 @@
                 <a:ea typeface="Arial" pitchFamily="34" charset="-122"/>
                 <a:cs typeface="Arial" pitchFamily="34" charset="-120"/>
               </a:rPr>
-              <a:t>Ask before telling. Co-create the new role so the employee owns the change.</a:t>
+              <a:t>Use GROW to surface the fear, identify strengths and co-create a safe experiment.</a:t>
             </a:r>
             <a:endParaRPr lang="en-US" sz="1500" dirty="0"/>
           </a:p>
@@ -10130,8 +10082,8 @@
         </p:nvSpPr>
         <p:spPr>
           <a:xfrm>
-            <a:off x="3163824" y="3017520"/>
-            <a:ext cx="219456" cy="566928"/>
+            <a:off x="3218688" y="3054096"/>
+            <a:ext cx="128016" cy="493776"/>
           </a:xfrm>
           <a:prstGeom prst="chevron">
             <a:avLst/>
@@ -10157,8 +10109,8 @@
         </p:nvSpPr>
         <p:spPr>
           <a:xfrm>
-            <a:off x="5925312" y="3017520"/>
-            <a:ext cx="219456" cy="566928"/>
+            <a:off x="5980176" y="3054096"/>
+            <a:ext cx="128016" cy="493776"/>
           </a:xfrm>
           <a:prstGeom prst="chevron">
             <a:avLst/>
@@ -10184,8 +10136,8 @@
         </p:nvSpPr>
         <p:spPr>
           <a:xfrm>
-            <a:off x="8686800" y="3017520"/>
-            <a:ext cx="219456" cy="566928"/>
+            <a:off x="8741664" y="3054096"/>
+            <a:ext cx="128016" cy="493776"/>
           </a:xfrm>
           <a:prstGeom prst="chevron">
             <a:avLst/>
@@ -10269,7 +10221,7 @@
                   <a:srgbClr val="FFFFFF"/>
                 </a:solidFill>
               </a:rPr>
-              <a:t>EMPATHY IS NOT A SOFT EXTRA. IT IS THE ADOPTION MECHANISM.</a:t>
+              <a:t>COACHING TURNS RESISTANCE INTO DESIGN INPUT.</a:t>
             </a:r>
             <a:endParaRPr lang="en-US" sz="1700" dirty="0"/>
           </a:p>
@@ -10285,7 +10237,7 @@
         </p:nvSpPr>
         <p:spPr>
           <a:xfrm>
-            <a:off x="658368" y="6428232"/>
+            <a:off x="658368" y="6355080"/>
             <a:ext cx="9921240" cy="219456"/>
           </a:xfrm>
           <a:prstGeom prst="rect">
@@ -10333,7 +10285,7 @@
         </p:nvSpPr>
         <p:spPr>
           <a:xfrm>
-            <a:off x="9464040" y="6446520"/>
+            <a:off x="9464040" y="6373368"/>
             <a:ext cx="2176272" cy="201168"/>
           </a:xfrm>
           <a:prstGeom prst="rect">
@@ -10454,7 +10406,7 @@
                 <a:ea typeface="Arial" pitchFamily="34" charset="-122"/>
                 <a:cs typeface="Arial" pitchFamily="34" charset="-120"/>
               </a:rPr>
-              <a:t>THE PRACTICE TOOL</a:t>
+              <a:t>THE PRODUCT</a:t>
             </a:r>
             <a:endParaRPr lang="en-US" sz="900" dirty="0"/>
           </a:p>
@@ -10534,7 +10486,7 @@
                 <a:ea typeface="Arial" pitchFamily="34" charset="-122"/>
                 <a:cs typeface="Arial" pitchFamily="34" charset="-120"/>
               </a:rPr>
-              <a:t>Practise before the real conversation.</a:t>
+              <a:t>Make the hard conversation safe to practise.</a:t>
             </a:r>
             <a:endParaRPr lang="en-US" sz="2900" dirty="0"/>
           </a:p>
@@ -10575,7 +10527,7 @@
                 <a:ea typeface="Arial" pitchFamily="34" charset="-122"/>
                 <a:cs typeface="Arial" pitchFamily="34" charset="-120"/>
               </a:rPr>
-              <a:t>Six scenarios let mentors rehearse resistance, redesign a role and receive GROW-based feedback.</a:t>
+              <a:t>The simulator builds coaching confidence across six realistic forms of resistance.</a:t>
             </a:r>
             <a:endParaRPr lang="en-US" sz="1500" dirty="0"/>
           </a:p>
@@ -10719,9 +10671,7 @@
       </p:sp>
       <p:sp>
         <p:nvSpPr>
-          <p:cNvPr id="12" name="Text 10">
-            <a:hlinkClick r:id="rId1" tooltip=""/>
-          </p:cNvPr>
+          <p:cNvPr id="12" name="Text 10"/>
           <p:cNvSpPr/>
           <p:nvPr/>
         </p:nvSpPr>
@@ -10744,17 +10694,10 @@
               <a:buNone/>
             </a:pPr>
             <a:r>
-              <a:rPr lang="en-US" sz="900" b="1" u="sng" spc="70" kern="0" dirty="0">
+              <a:rPr lang="en-US" sz="900" b="1" spc="70" kern="0" dirty="0">
                 <a:solidFill>
                   <a:srgbClr val="FFFFFF"/>
                 </a:solidFill>
-                <a:hlinkClick r:id="rId1" invalidUrl="" action="" tgtFrame="" tooltip="" history="1" highlightClick="0" endSnd="0">
-                  <a:extLst>
-                    <a:ext uri="{A12FA001-AC4F-418D-AE19-62706E023703}">
-                      <ahyp:hlinkClr xmlns:ahyp="http://schemas.microsoft.com/office/drawing/2018/hyperlinkcolor" val="tx"/>
-                    </a:ext>
-                  </a:extLst>
-                </a:hlinkClick>
               </a:rPr>
               <a:t>AI AGENT JOB REDESIGN COACH - LIVE SIMULATOR</a:t>
             </a:r>
@@ -10917,7 +10860,7 @@
               <a:buNone/>
             </a:pPr>
             <a:r>
-              <a:rPr lang="en-US" sz="750" b="1" dirty="0">
+              <a:rPr lang="en-US" sz="800" b="1" dirty="0">
                 <a:solidFill>
                   <a:srgbClr val="4F6176"/>
                 </a:solidFill>
@@ -10925,9 +10868,9 @@
                 <a:ea typeface="Arial" pitchFamily="34" charset="-122"/>
                 <a:cs typeface="Arial" pitchFamily="34" charset="-120"/>
               </a:rPr>
-              <a:t>FEAR + IDENTITY</a:t>
-            </a:r>
-            <a:endParaRPr lang="en-US" sz="750" dirty="0"/>
+              <a:t>FEAR / IDENTITY</a:t>
+            </a:r>
+            <a:endParaRPr lang="en-US" sz="800" dirty="0"/>
           </a:p>
         </p:txBody>
       </p:sp>
@@ -11086,7 +11029,7 @@
               <a:buNone/>
             </a:pPr>
             <a:r>
-              <a:rPr lang="en-US" sz="750" b="1" dirty="0">
+              <a:rPr lang="en-US" sz="800" b="1" dirty="0">
                 <a:solidFill>
                   <a:srgbClr val="4F6176"/>
                 </a:solidFill>
@@ -11094,9 +11037,9 @@
                 <a:ea typeface="Arial" pitchFamily="34" charset="-122"/>
                 <a:cs typeface="Arial" pitchFamily="34" charset="-120"/>
               </a:rPr>
-              <a:t>ANGER + BETRAYAL</a:t>
-            </a:r>
-            <a:endParaRPr lang="en-US" sz="750" dirty="0"/>
+              <a:t>ANGER / TRUST</a:t>
+            </a:r>
+            <a:endParaRPr lang="en-US" sz="800" dirty="0"/>
           </a:p>
         </p:txBody>
       </p:sp>
@@ -11255,7 +11198,7 @@
               <a:buNone/>
             </a:pPr>
             <a:r>
-              <a:rPr lang="en-US" sz="750" b="1" dirty="0">
+              <a:rPr lang="en-US" sz="800" b="1" dirty="0">
                 <a:solidFill>
                   <a:srgbClr val="4F6176"/>
                 </a:solidFill>
@@ -11263,9 +11206,9 @@
                 <a:ea typeface="Arial" pitchFamily="34" charset="-122"/>
                 <a:cs typeface="Arial" pitchFamily="34" charset="-120"/>
               </a:rPr>
-              <a:t>ANXIETY + WITHDRAWAL</a:t>
-            </a:r>
-            <a:endParaRPr lang="en-US" sz="750" dirty="0"/>
+              <a:t>ANXIETY / WITHDRAWAL</a:t>
+            </a:r>
+            <a:endParaRPr lang="en-US" sz="800" dirty="0"/>
           </a:p>
         </p:txBody>
       </p:sp>
@@ -11424,7 +11367,7 @@
               <a:buNone/>
             </a:pPr>
             <a:r>
-              <a:rPr lang="en-US" sz="750" b="1" dirty="0">
+              <a:rPr lang="en-US" sz="800" b="1" dirty="0">
                 <a:solidFill>
                   <a:srgbClr val="4F6176"/>
                 </a:solidFill>
@@ -11432,9 +11375,9 @@
                 <a:ea typeface="Arial" pitchFamily="34" charset="-122"/>
                 <a:cs typeface="Arial" pitchFamily="34" charset="-120"/>
               </a:rPr>
-              <a:t>SCEPTICISM + PRIDE</a:t>
-            </a:r>
-            <a:endParaRPr lang="en-US" sz="750" dirty="0"/>
+              <a:t>SCEPTICISM / PRIDE</a:t>
+            </a:r>
+            <a:endParaRPr lang="en-US" sz="800" dirty="0"/>
           </a:p>
         </p:txBody>
       </p:sp>
@@ -11593,7 +11536,7 @@
               <a:buNone/>
             </a:pPr>
             <a:r>
-              <a:rPr lang="en-US" sz="750" b="1" dirty="0">
+              <a:rPr lang="en-US" sz="800" b="1" dirty="0">
                 <a:solidFill>
                   <a:srgbClr val="4F6176"/>
                 </a:solidFill>
@@ -11601,9 +11544,9 @@
                 <a:ea typeface="Arial" pitchFamily="34" charset="-122"/>
                 <a:cs typeface="Arial" pitchFamily="34" charset="-120"/>
               </a:rPr>
-              <a:t>CONTROL + ACCOUNTABILITY</a:t>
-            </a:r>
-            <a:endParaRPr lang="en-US" sz="750" dirty="0"/>
+              <a:t>CONTROL / ACCOUNTABILITY</a:t>
+            </a:r>
+            <a:endParaRPr lang="en-US" sz="800" dirty="0"/>
           </a:p>
         </p:txBody>
       </p:sp>
@@ -11762,7 +11705,7 @@
               <a:buNone/>
             </a:pPr>
             <a:r>
-              <a:rPr lang="en-US" sz="750" b="1" dirty="0">
+              <a:rPr lang="en-US" sz="800" b="1" dirty="0">
                 <a:solidFill>
                   <a:srgbClr val="4F6176"/>
                 </a:solidFill>
@@ -11770,9 +11713,9 @@
                 <a:ea typeface="Arial" pitchFamily="34" charset="-122"/>
                 <a:cs typeface="Arial" pitchFamily="34" charset="-120"/>
               </a:rPr>
-              <a:t>ETHICS + PURPOSE</a:t>
-            </a:r>
-            <a:endParaRPr lang="en-US" sz="750" dirty="0"/>
+              <a:t>ETHICS / PURPOSE</a:t>
+            </a:r>
+            <a:endParaRPr lang="en-US" sz="800" dirty="0"/>
           </a:p>
         </p:txBody>
       </p:sp>
@@ -11805,9 +11748,7 @@
       </p:sp>
       <p:sp>
         <p:nvSpPr>
-          <p:cNvPr id="44" name="Text 42">
-            <a:hlinkClick r:id="rId2" tooltip=""/>
-          </p:cNvPr>
+          <p:cNvPr id="44" name="Text 42"/>
           <p:cNvSpPr/>
           <p:nvPr/>
         </p:nvSpPr>
@@ -11832,11 +11773,49 @@
               <a:buNone/>
             </a:pPr>
             <a:r>
-              <a:rPr lang="en-US" sz="1100" b="1" u="sng" spc="45" kern="0" dirty="0">
+              <a:rPr lang="en-US" sz="1100" b="1" spc="45" kern="0" dirty="0">
                 <a:solidFill>
                   <a:srgbClr val="FFFFFF"/>
                 </a:solidFill>
-                <a:hlinkClick r:id="rId2" invalidUrl="" action="" tgtFrame="" tooltip="" history="1" highlightClick="0" endSnd="0">
+              </a:rPr>
+              <a:t>PICK A PERSON  &gt;  COACH THE TRANSITION  &gt;  GET GROW FEEDBACK</a:t>
+            </a:r>
+            <a:endParaRPr lang="en-US" sz="1100" dirty="0"/>
+          </a:p>
+        </p:txBody>
+      </p:sp>
+      <p:sp>
+        <p:nvSpPr>
+          <p:cNvPr id="45" name="Text 43">
+            <a:hlinkClick r:id="rId1" tooltip=""/>
+          </p:cNvPr>
+          <p:cNvSpPr/>
+          <p:nvPr/>
+        </p:nvSpPr>
+        <p:spPr>
+          <a:xfrm>
+            <a:off x="2852928" y="5669280"/>
+            <a:ext cx="3474720" cy="219456"/>
+          </a:xfrm>
+          <a:prstGeom prst="rect">
+            <a:avLst/>
+          </a:prstGeom>
+          <a:noFill/>
+          <a:ln/>
+        </p:spPr>
+        <p:txBody>
+          <a:bodyPr wrap="square" lIns="0" tIns="0" rIns="0" bIns="0" rtlCol="0" anchor="ctr"/>
+          <a:lstStyle/>
+          <a:p>
+            <a:pPr algn="ctr" indent="0" marL="0">
+              <a:buNone/>
+            </a:pPr>
+            <a:r>
+              <a:rPr lang="en-US" sz="1200" b="1" u="sng" spc="100" kern="0" dirty="0">
+                <a:solidFill>
+                  <a:srgbClr val="0B6E75"/>
+                </a:solidFill>
+                <a:hlinkClick r:id="rId1" invalidUrl="" action="" tgtFrame="" tooltip="" history="1" highlightClick="0" endSnd="0">
                   <a:extLst>
                     <a:ext uri="{A12FA001-AC4F-418D-AE19-62706E023703}">
                       <ahyp:hlinkClr xmlns:ahyp="http://schemas.microsoft.com/office/drawing/2018/hyperlinkcolor" val="tx"/>
@@ -11844,52 +11823,7 @@
                   </a:extLst>
                 </a:hlinkClick>
               </a:rPr>
-              <a:t>PICK A PERSON  &gt;  COACH THE TRANSITION  &gt;  GET GROW FEEDBACK</a:t>
-            </a:r>
-            <a:endParaRPr lang="en-US" sz="1100" dirty="0"/>
-          </a:p>
-        </p:txBody>
-      </p:sp>
-      <p:sp>
-        <p:nvSpPr>
-          <p:cNvPr id="45" name="Text 43">
-            <a:hlinkClick r:id="rId3" tooltip=""/>
-          </p:cNvPr>
-          <p:cNvSpPr/>
-          <p:nvPr/>
-        </p:nvSpPr>
-        <p:spPr>
-          <a:xfrm>
-            <a:off x="2852928" y="5669280"/>
-            <a:ext cx="3474720" cy="219456"/>
-          </a:xfrm>
-          <a:prstGeom prst="rect">
-            <a:avLst/>
-          </a:prstGeom>
-          <a:noFill/>
-          <a:ln/>
-        </p:spPr>
-        <p:txBody>
-          <a:bodyPr wrap="square" lIns="0" tIns="0" rIns="0" bIns="0" rtlCol="0" anchor="ctr"/>
-          <a:lstStyle/>
-          <a:p>
-            <a:pPr algn="ctr" indent="0" marL="0">
-              <a:buNone/>
-            </a:pPr>
-            <a:r>
-              <a:rPr lang="en-US" sz="1200" b="1" u="sng" spc="100" kern="0" dirty="0">
-                <a:solidFill>
-                  <a:srgbClr val="0B6E75"/>
-                </a:solidFill>
-                <a:hlinkClick r:id="rId3" invalidUrl="" action="" tgtFrame="" tooltip="" history="1" highlightClick="0" endSnd="0">
-                  <a:extLst>
-                    <a:ext uri="{A12FA001-AC4F-418D-AE19-62706E023703}">
-                      <ahyp:hlinkClr xmlns:ahyp="http://schemas.microsoft.com/office/drawing/2018/hyperlinkcolor" val="tx"/>
-                    </a:ext>
-                  </a:extLst>
-                </a:hlinkClick>
-              </a:rPr>
-              <a:t>CLICK TO OPEN LIVE SIMULATOR</a:t>
+              <a:t>OPEN LIVE SIMULATOR</a:t>
             </a:r>
             <a:endParaRPr lang="en-US" sz="1200" dirty="0"/>
           </a:p>
@@ -11968,7 +11902,7 @@
       <p:pic>
         <p:nvPicPr>
           <p:cNvPr id="48" name="Image 0" descr="QR code to the live AI Agent Job Redesign Coach">
-            <a:hlinkClick r:id="rId5" tooltip=""/>
+            <a:hlinkClick r:id="rId3" tooltip=""/>
           </p:cNvPr>
           <p:cNvPicPr>
             <a:picLocks noChangeAspect="1"/>
@@ -11976,7 +11910,7 @@
           <p:nvPr/>
         </p:nvPicPr>
         <p:blipFill>
-          <a:blip r:embed="rId4"/>
+          <a:blip r:embed="rId2"/>
           <a:stretch>
             <a:fillRect/>
           </a:stretch>
@@ -12043,36 +11977,79 @@
       </p:sp>
       <p:sp>
         <p:nvSpPr>
-          <p:cNvPr id="50" name="Text 47">
-            <a:hlinkClick r:id="rId6" tooltip=""/>
+          <p:cNvPr id="50" name="Text 47"/>
+          <p:cNvSpPr/>
+          <p:nvPr/>
+        </p:nvSpPr>
+        <p:spPr>
+          <a:xfrm>
+            <a:off x="8979408" y="5230368"/>
+            <a:ext cx="2395728" cy="219456"/>
+          </a:xfrm>
+          <a:prstGeom prst="rect">
+            <a:avLst/>
+          </a:prstGeom>
+          <a:noFill/>
+          <a:ln/>
+        </p:spPr>
+        <p:txBody>
+          <a:bodyPr wrap="square" lIns="0" tIns="0" rIns="0" bIns="0" rtlCol="0" anchor="ctr">
+            <a:normAutofit/>
+          </a:bodyPr>
+          <a:lstStyle/>
+          <a:p>
+            <a:pPr algn="ctr" indent="0" marL="0">
+              <a:buNone/>
+            </a:pPr>
+            <a:r>
+              <a:rPr lang="en-US" sz="950" dirty="0">
+                <a:solidFill>
+                  <a:srgbClr val="C7E3E7"/>
+                </a:solidFill>
+              </a:rPr>
+              <a:t>alfredang.github.io/AICoahcing</a:t>
+            </a:r>
+            <a:endParaRPr lang="en-US" sz="950" dirty="0"/>
+          </a:p>
+        </p:txBody>
+      </p:sp>
+      <p:sp>
+        <p:nvSpPr>
+          <p:cNvPr id="51" name="Text 48">
+            <a:hlinkClick r:id="rId4" tooltip=""/>
           </p:cNvPr>
           <p:cNvSpPr/>
           <p:nvPr/>
         </p:nvSpPr>
         <p:spPr>
           <a:xfrm>
-            <a:off x="9144000" y="5138928"/>
-            <a:ext cx="2084832" cy="457200"/>
-          </a:xfrm>
-          <a:prstGeom prst="rect">
-            <a:avLst/>
-          </a:prstGeom>
-          <a:noFill/>
-          <a:ln/>
-        </p:spPr>
-        <p:txBody>
-          <a:bodyPr wrap="square" lIns="0" tIns="0" rIns="0" bIns="0" rtlCol="0" anchor="ctr"/>
-          <a:lstStyle/>
-          <a:p>
-            <a:pPr algn="ctr" indent="0" marL="0">
-              <a:buNone/>
-            </a:pPr>
-            <a:r>
-              <a:rPr lang="en-US" sz="1250" u="sng" dirty="0">
-                <a:solidFill>
-                  <a:srgbClr val="C7E3E7"/>
-                </a:solidFill>
-                <a:hlinkClick r:id="rId6" invalidUrl="" action="" tgtFrame="" tooltip="" history="1" highlightClick="0" endSnd="0">
+            <a:off x="658368" y="6355080"/>
+            <a:ext cx="9921240" cy="219456"/>
+          </a:xfrm>
+          <a:prstGeom prst="rect">
+            <a:avLst/>
+          </a:prstGeom>
+          <a:noFill/>
+          <a:ln/>
+        </p:spPr>
+        <p:txBody>
+          <a:bodyPr wrap="square" lIns="0" tIns="0" rIns="0" bIns="0" rtlCol="0" anchor="ctr">
+            <a:normAutofit/>
+          </a:bodyPr>
+          <a:lstStyle/>
+          <a:p>
+            <a:pPr indent="0" marL="0">
+              <a:buNone/>
+            </a:pPr>
+            <a:r>
+              <a:rPr lang="en-US" sz="1000" u="sng" dirty="0">
+                <a:solidFill>
+                  <a:srgbClr val="728197"/>
+                </a:solidFill>
+                <a:latin typeface="Arial" pitchFamily="34" charset="0"/>
+                <a:ea typeface="Arial" pitchFamily="34" charset="-122"/>
+                <a:cs typeface="Arial" pitchFamily="34" charset="-120"/>
+                <a:hlinkClick r:id="rId4" invalidUrl="" action="" tgtFrame="" tooltip="" history="1" highlightClick="0" endSnd="0">
                   <a:extLst>
                     <a:ext uri="{A12FA001-AC4F-418D-AE19-62706E023703}">
                       <ahyp:hlinkClr xmlns:ahyp="http://schemas.microsoft.com/office/drawing/2018/hyperlinkcolor" val="tx"/>
@@ -12080,77 +12057,6 @@
                   </a:extLst>
                 </a:hlinkClick>
               </a:rPr>
-              <a:t>alfredang.github.io/</a:t>
-            </a:r>
-            <a:endParaRPr lang="en-US" sz="1250" dirty="0"/>
-          </a:p>
-          <a:p>
-            <a:pPr algn="ctr" indent="0" marL="0">
-              <a:buNone/>
-            </a:pPr>
-            <a:r>
-              <a:rPr lang="en-US" sz="1250" u="sng" dirty="0">
-                <a:solidFill>
-                  <a:srgbClr val="C7E3E7"/>
-                </a:solidFill>
-                <a:hlinkClick r:id="rId6" invalidUrl="" action="" tgtFrame="" tooltip="" history="1" highlightClick="0" endSnd="0">
-                  <a:extLst>
-                    <a:ext uri="{A12FA001-AC4F-418D-AE19-62706E023703}">
-                      <ahyp:hlinkClr xmlns:ahyp="http://schemas.microsoft.com/office/drawing/2018/hyperlinkcolor" val="tx"/>
-                    </a:ext>
-                  </a:extLst>
-                </a:hlinkClick>
-              </a:rPr>
-              <a:t>AICoahcing</a:t>
-            </a:r>
-            <a:endParaRPr lang="en-US" sz="1250" dirty="0"/>
-          </a:p>
-        </p:txBody>
-      </p:sp>
-      <p:sp>
-        <p:nvSpPr>
-          <p:cNvPr id="51" name="Text 48">
-            <a:hlinkClick r:id="rId7" tooltip=""/>
-          </p:cNvPr>
-          <p:cNvSpPr/>
-          <p:nvPr/>
-        </p:nvSpPr>
-        <p:spPr>
-          <a:xfrm>
-            <a:off x="658368" y="6428232"/>
-            <a:ext cx="9921240" cy="219456"/>
-          </a:xfrm>
-          <a:prstGeom prst="rect">
-            <a:avLst/>
-          </a:prstGeom>
-          <a:noFill/>
-          <a:ln/>
-        </p:spPr>
-        <p:txBody>
-          <a:bodyPr wrap="square" lIns="0" tIns="0" rIns="0" bIns="0" rtlCol="0" anchor="ctr">
-            <a:normAutofit/>
-          </a:bodyPr>
-          <a:lstStyle/>
-          <a:p>
-            <a:pPr indent="0" marL="0">
-              <a:buNone/>
-            </a:pPr>
-            <a:r>
-              <a:rPr lang="en-US" sz="1000" u="sng" dirty="0">
-                <a:solidFill>
-                  <a:srgbClr val="728197"/>
-                </a:solidFill>
-                <a:latin typeface="Arial" pitchFamily="34" charset="0"/>
-                <a:ea typeface="Arial" pitchFamily="34" charset="-122"/>
-                <a:cs typeface="Arial" pitchFamily="34" charset="-120"/>
-                <a:hlinkClick r:id="rId7" invalidUrl="" action="" tgtFrame="" tooltip="" history="1" highlightClick="0" endSnd="0">
-                  <a:extLst>
-                    <a:ext uri="{A12FA001-AC4F-418D-AE19-62706E023703}">
-                      <ahyp:hlinkClr xmlns:ahyp="http://schemas.microsoft.com/office/drawing/2018/hyperlinkcolor" val="tx"/>
-                    </a:ext>
-                  </a:extLst>
-                </a:hlinkClick>
-              </a:rPr>
               <a:t>Live training simulator - six fictional scenarios; demo mode makes no external API calls</a:t>
             </a:r>
             <a:endParaRPr lang="en-US" sz="1000" dirty="0"/>
@@ -12165,7 +12071,7 @@
         </p:nvSpPr>
         <p:spPr>
           <a:xfrm>
-            <a:off x="9464040" y="6446520"/>
+            <a:off x="9464040" y="6373368"/>
             <a:ext cx="2176272" cy="201168"/>
           </a:xfrm>
           <a:prstGeom prst="rect">
@@ -12286,7 +12192,7 @@
                 <a:ea typeface="Arial" pitchFamily="34" charset="-122"/>
                 <a:cs typeface="Arial" pitchFamily="34" charset="-120"/>
               </a:rPr>
-              <a:t>ONE WORKED EXAMPLE</a:t>
+              <a:t>THE WORKED EXAMPLE</a:t>
             </a:r>
             <a:endParaRPr lang="en-US" sz="900" dirty="0"/>
           </a:p>
@@ -12366,7 +12272,7 @@
                 <a:ea typeface="Arial" pitchFamily="34" charset="-122"/>
                 <a:cs typeface="Arial" pitchFamily="34" charset="-120"/>
               </a:rPr>
-              <a:t>Sarah did not need reassurance. She needed a new role.</a:t>
+              <a:t>A coaching conversation can reframe fear as ownership.</a:t>
             </a:r>
             <a:endParaRPr lang="en-US" sz="2900" dirty="0"/>
           </a:p>
@@ -12407,7 +12313,7 @@
                 <a:ea typeface="Arial" pitchFamily="34" charset="-122"/>
                 <a:cs typeface="Arial" pitchFamily="34" charset="-120"/>
               </a:rPr>
-              <a:t>The coaching conversation moved from fear of redundancy to supported human ownership.</a:t>
+              <a:t>Sarah moves from threatened doer to AI-augmented marketing lead.</a:t>
             </a:r>
             <a:endParaRPr lang="en-US" sz="1500" dirty="0"/>
           </a:p>
@@ -13216,7 +13122,7 @@
         </p:nvSpPr>
         <p:spPr>
           <a:xfrm>
-            <a:off x="658368" y="6428232"/>
+            <a:off x="658368" y="6355080"/>
             <a:ext cx="9921240" cy="219456"/>
           </a:xfrm>
           <a:prstGeom prst="rect">
@@ -13264,7 +13170,7 @@
         </p:nvSpPr>
         <p:spPr>
           <a:xfrm>
-            <a:off x="9464040" y="6446520"/>
+            <a:off x="9464040" y="6373368"/>
             <a:ext cx="2176272" cy="201168"/>
           </a:xfrm>
           <a:prstGeom prst="rect">

</xml_diff>

<commit_message>
feat: add live simulator launch button
</commit_message>
<xml_diff>
--- a/presentation/Dr-Alfred-Work-Redesign-for-Managing-AI-Agents.pptx
+++ b/presentation/Dr-Alfred-Work-Redesign-for-Managing-AI-Agents.pptx
@@ -1224,7 +1224,7 @@
             <a:r>
               <a:rPr lang="en-US" dirty="0"/>
               <a:t>Timing: 6:10-7:20
-This is the practical product: six scenarios spanning fear, anger, anxiety, scepticism, accountability and ethical purpose. Demo one exchange and show that the staff member opens up when the manager combines empathy with concrete ownership. No-key mode makes the practice reliable in workshops.</a:t>
+This is the practical product: six scenarios spanning fear, anger, anxiety, scepticism, accountability and ethical purpose. In Slide Show mode, click the large gold launch button to open the live simulator, or invite the audience to scan the QR code. Demo one exchange and show that the staff member opens up when the manager combines empathy with concrete ownership. No-key mode makes the practice reliable in workshops.</a:t>
             </a:r>
             <a:endParaRPr lang="en-US" dirty="0"/>
           </a:p>
@@ -10860,9 +10860,9 @@
               <a:buNone/>
             </a:pPr>
             <a:r>
-              <a:rPr lang="en-US" sz="800" b="1" dirty="0">
-                <a:solidFill>
-                  <a:srgbClr val="4F6176"/>
+              <a:rPr lang="en-US" sz="900" b="1" dirty="0">
+                <a:solidFill>
+                  <a:srgbClr val="12233F"/>
                 </a:solidFill>
                 <a:latin typeface="Arial" pitchFamily="34" charset="0"/>
                 <a:ea typeface="Arial" pitchFamily="34" charset="-122"/>
@@ -10870,7 +10870,7 @@
               </a:rPr>
               <a:t>FEAR / IDENTITY</a:t>
             </a:r>
-            <a:endParaRPr lang="en-US" sz="800" dirty="0"/>
+            <a:endParaRPr lang="en-US" sz="900" dirty="0"/>
           </a:p>
         </p:txBody>
       </p:sp>
@@ -11029,9 +11029,9 @@
               <a:buNone/>
             </a:pPr>
             <a:r>
-              <a:rPr lang="en-US" sz="800" b="1" dirty="0">
-                <a:solidFill>
-                  <a:srgbClr val="4F6176"/>
+              <a:rPr lang="en-US" sz="900" b="1" dirty="0">
+                <a:solidFill>
+                  <a:srgbClr val="12233F"/>
                 </a:solidFill>
                 <a:latin typeface="Arial" pitchFamily="34" charset="0"/>
                 <a:ea typeface="Arial" pitchFamily="34" charset="-122"/>
@@ -11039,7 +11039,7 @@
               </a:rPr>
               <a:t>ANGER / TRUST</a:t>
             </a:r>
-            <a:endParaRPr lang="en-US" sz="800" dirty="0"/>
+            <a:endParaRPr lang="en-US" sz="900" dirty="0"/>
           </a:p>
         </p:txBody>
       </p:sp>
@@ -11198,9 +11198,9 @@
               <a:buNone/>
             </a:pPr>
             <a:r>
-              <a:rPr lang="en-US" sz="800" b="1" dirty="0">
-                <a:solidFill>
-                  <a:srgbClr val="4F6176"/>
+              <a:rPr lang="en-US" sz="900" b="1" dirty="0">
+                <a:solidFill>
+                  <a:srgbClr val="12233F"/>
                 </a:solidFill>
                 <a:latin typeface="Arial" pitchFamily="34" charset="0"/>
                 <a:ea typeface="Arial" pitchFamily="34" charset="-122"/>
@@ -11208,7 +11208,7 @@
               </a:rPr>
               <a:t>ANXIETY / WITHDRAWAL</a:t>
             </a:r>
-            <a:endParaRPr lang="en-US" sz="800" dirty="0"/>
+            <a:endParaRPr lang="en-US" sz="900" dirty="0"/>
           </a:p>
         </p:txBody>
       </p:sp>
@@ -11367,9 +11367,9 @@
               <a:buNone/>
             </a:pPr>
             <a:r>
-              <a:rPr lang="en-US" sz="800" b="1" dirty="0">
-                <a:solidFill>
-                  <a:srgbClr val="4F6176"/>
+              <a:rPr lang="en-US" sz="900" b="1" dirty="0">
+                <a:solidFill>
+                  <a:srgbClr val="12233F"/>
                 </a:solidFill>
                 <a:latin typeface="Arial" pitchFamily="34" charset="0"/>
                 <a:ea typeface="Arial" pitchFamily="34" charset="-122"/>
@@ -11377,7 +11377,7 @@
               </a:rPr>
               <a:t>SCEPTICISM / PRIDE</a:t>
             </a:r>
-            <a:endParaRPr lang="en-US" sz="800" dirty="0"/>
+            <a:endParaRPr lang="en-US" sz="900" dirty="0"/>
           </a:p>
         </p:txBody>
       </p:sp>
@@ -11536,9 +11536,9 @@
               <a:buNone/>
             </a:pPr>
             <a:r>
-              <a:rPr lang="en-US" sz="800" b="1" dirty="0">
-                <a:solidFill>
-                  <a:srgbClr val="4F6176"/>
+              <a:rPr lang="en-US" sz="900" b="1" dirty="0">
+                <a:solidFill>
+                  <a:srgbClr val="12233F"/>
                 </a:solidFill>
                 <a:latin typeface="Arial" pitchFamily="34" charset="0"/>
                 <a:ea typeface="Arial" pitchFamily="34" charset="-122"/>
@@ -11546,7 +11546,7 @@
               </a:rPr>
               <a:t>CONTROL / ACCOUNTABILITY</a:t>
             </a:r>
-            <a:endParaRPr lang="en-US" sz="800" dirty="0"/>
+            <a:endParaRPr lang="en-US" sz="900" dirty="0"/>
           </a:p>
         </p:txBody>
       </p:sp>
@@ -11705,9 +11705,9 @@
               <a:buNone/>
             </a:pPr>
             <a:r>
-              <a:rPr lang="en-US" sz="800" b="1" dirty="0">
-                <a:solidFill>
-                  <a:srgbClr val="4F6176"/>
+              <a:rPr lang="en-US" sz="900" b="1" dirty="0">
+                <a:solidFill>
+                  <a:srgbClr val="12233F"/>
                 </a:solidFill>
                 <a:latin typeface="Arial" pitchFamily="34" charset="0"/>
                 <a:ea typeface="Arial" pitchFamily="34" charset="-122"/>
@@ -11715,7 +11715,7 @@
               </a:rPr>
               <a:t>ETHICS / PURPOSE</a:t>
             </a:r>
-            <a:endParaRPr lang="en-US" sz="800" dirty="0"/>
+            <a:endParaRPr lang="en-US" sz="900" dirty="0"/>
           </a:p>
         </p:txBody>
       </p:sp>
@@ -11786,52 +11786,7 @@
       </p:sp>
       <p:sp>
         <p:nvSpPr>
-          <p:cNvPr id="45" name="Text 43">
-            <a:hlinkClick r:id="rId1" tooltip=""/>
-          </p:cNvPr>
-          <p:cNvSpPr/>
-          <p:nvPr/>
-        </p:nvSpPr>
-        <p:spPr>
-          <a:xfrm>
-            <a:off x="2852928" y="5669280"/>
-            <a:ext cx="3474720" cy="219456"/>
-          </a:xfrm>
-          <a:prstGeom prst="rect">
-            <a:avLst/>
-          </a:prstGeom>
-          <a:noFill/>
-          <a:ln/>
-        </p:spPr>
-        <p:txBody>
-          <a:bodyPr wrap="square" lIns="0" tIns="0" rIns="0" bIns="0" rtlCol="0" anchor="ctr"/>
-          <a:lstStyle/>
-          <a:p>
-            <a:pPr algn="ctr" indent="0" marL="0">
-              <a:buNone/>
-            </a:pPr>
-            <a:r>
-              <a:rPr lang="en-US" sz="1200" b="1" u="sng" spc="100" kern="0" dirty="0">
-                <a:solidFill>
-                  <a:srgbClr val="0B6E75"/>
-                </a:solidFill>
-                <a:hlinkClick r:id="rId1" invalidUrl="" action="" tgtFrame="" tooltip="" history="1" highlightClick="0" endSnd="0">
-                  <a:extLst>
-                    <a:ext uri="{A12FA001-AC4F-418D-AE19-62706E023703}">
-                      <ahyp:hlinkClr xmlns:ahyp="http://schemas.microsoft.com/office/drawing/2018/hyperlinkcolor" val="tx"/>
-                    </a:ext>
-                  </a:extLst>
-                </a:hlinkClick>
-              </a:rPr>
-              <a:t>OPEN LIVE SIMULATOR</a:t>
-            </a:r>
-            <a:endParaRPr lang="en-US" sz="1200" dirty="0"/>
-          </a:p>
-        </p:txBody>
-      </p:sp>
-      <p:sp>
-        <p:nvSpPr>
-          <p:cNvPr id="46" name="Shape 44"/>
+          <p:cNvPr id="45" name="Shape 43"/>
           <p:cNvSpPr/>
           <p:nvPr/>
         </p:nvSpPr>
@@ -11865,126 +11820,14 @@
       </p:sp>
       <p:sp>
         <p:nvSpPr>
-          <p:cNvPr id="47" name="Text 45"/>
-          <p:cNvSpPr/>
-          <p:nvPr/>
-        </p:nvSpPr>
-        <p:spPr>
-          <a:xfrm>
-            <a:off x="9144000" y="1956816"/>
-            <a:ext cx="2084832" cy="274320"/>
-          </a:xfrm>
-          <a:prstGeom prst="rect">
-            <a:avLst/>
-          </a:prstGeom>
-          <a:noFill/>
-          <a:ln/>
-        </p:spPr>
-        <p:txBody>
-          <a:bodyPr wrap="square" lIns="0" tIns="0" rIns="0" bIns="0" rtlCol="0" anchor="ctr"/>
-          <a:lstStyle/>
-          <a:p>
-            <a:pPr algn="ctr" indent="0" marL="0">
-              <a:buNone/>
-            </a:pPr>
-            <a:r>
-              <a:rPr lang="en-US" sz="1500" b="1" spc="120" kern="0" dirty="0">
-                <a:solidFill>
-                  <a:srgbClr val="55D6BE"/>
-                </a:solidFill>
-              </a:rPr>
-              <a:t>TRY IT</a:t>
-            </a:r>
-            <a:endParaRPr lang="en-US" sz="1500" dirty="0"/>
-          </a:p>
-        </p:txBody>
-      </p:sp>
-      <p:pic>
-        <p:nvPicPr>
-          <p:cNvPr id="48" name="Image 0" descr="QR code to the live AI Agent Job Redesign Coach">
-            <a:hlinkClick r:id="rId3" tooltip=""/>
-          </p:cNvPr>
-          <p:cNvPicPr>
-            <a:picLocks noChangeAspect="1"/>
-          </p:cNvPicPr>
-          <p:nvPr/>
-        </p:nvPicPr>
-        <p:blipFill>
-          <a:blip r:embed="rId2"/>
-          <a:stretch>
-            <a:fillRect/>
-          </a:stretch>
-        </p:blipFill>
-        <p:spPr>
-          <a:xfrm>
-            <a:off x="9262872" y="2395728"/>
-            <a:ext cx="1828800" cy="1828800"/>
-          </a:xfrm>
-          <a:prstGeom prst="rect">
-            <a:avLst/>
-          </a:prstGeom>
-        </p:spPr>
-      </p:pic>
-      <p:sp>
-        <p:nvSpPr>
-          <p:cNvPr id="49" name="Text 46"/>
-          <p:cNvSpPr/>
-          <p:nvPr/>
-        </p:nvSpPr>
-        <p:spPr>
-          <a:xfrm>
-            <a:off x="9144000" y="4425696"/>
-            <a:ext cx="2084832" cy="548640"/>
-          </a:xfrm>
-          <a:prstGeom prst="rect">
-            <a:avLst/>
-          </a:prstGeom>
-          <a:noFill/>
-          <a:ln/>
-        </p:spPr>
-        <p:txBody>
-          <a:bodyPr wrap="square" lIns="0" tIns="0" rIns="0" bIns="0" rtlCol="0" anchor="ctr"/>
-          <a:lstStyle/>
-          <a:p>
-            <a:pPr algn="ctr" indent="0" marL="0">
-              <a:buNone/>
-            </a:pPr>
-            <a:r>
-              <a:rPr lang="en-US" sz="1700" b="1" dirty="0">
-                <a:solidFill>
-                  <a:srgbClr val="FFFFFF"/>
-                </a:solidFill>
-              </a:rPr>
-              <a:t>No API key needed</a:t>
-            </a:r>
-            <a:endParaRPr lang="en-US" sz="1700" dirty="0"/>
-          </a:p>
-          <a:p>
-            <a:pPr algn="ctr" indent="0" marL="0">
-              <a:buNone/>
-            </a:pPr>
-            <a:r>
-              <a:rPr lang="en-US" sz="1700" b="1" dirty="0">
-                <a:solidFill>
-                  <a:srgbClr val="FFFFFF"/>
-                </a:solidFill>
-              </a:rPr>
-              <a:t>in demo mode</a:t>
-            </a:r>
-            <a:endParaRPr lang="en-US" sz="1700" dirty="0"/>
-          </a:p>
-        </p:txBody>
-      </p:sp>
-      <p:sp>
-        <p:nvSpPr>
-          <p:cNvPr id="50" name="Text 47"/>
-          <p:cNvSpPr/>
-          <p:nvPr/>
-        </p:nvSpPr>
-        <p:spPr>
-          <a:xfrm>
-            <a:off x="8979408" y="5230368"/>
-            <a:ext cx="2395728" cy="219456"/>
+          <p:cNvPr id="46" name="Text 44"/>
+          <p:cNvSpPr/>
+          <p:nvPr/>
+        </p:nvSpPr>
+        <p:spPr>
+          <a:xfrm>
+            <a:off x="8979408" y="1901952"/>
+            <a:ext cx="2414016" cy="274320"/>
           </a:xfrm>
           <a:prstGeom prst="rect">
             <a:avLst/>
@@ -12002,54 +11845,112 @@
               <a:buNone/>
             </a:pPr>
             <a:r>
-              <a:rPr lang="en-US" sz="950" dirty="0">
-                <a:solidFill>
-                  <a:srgbClr val="C7E3E7"/>
-                </a:solidFill>
-              </a:rPr>
-              <a:t>alfredang.github.io/AICoahcing</a:t>
-            </a:r>
-            <a:endParaRPr lang="en-US" sz="950" dirty="0"/>
-          </a:p>
-        </p:txBody>
-      </p:sp>
-      <p:sp>
-        <p:nvSpPr>
-          <p:cNvPr id="51" name="Text 48">
-            <a:hlinkClick r:id="rId4" tooltip=""/>
+              <a:rPr lang="en-US" sz="1300" b="1" spc="70" kern="0" dirty="0">
+                <a:solidFill>
+                  <a:srgbClr val="55D6BE"/>
+                </a:solidFill>
+              </a:rPr>
+              <a:t>OPEN LIVE SIMULATOR</a:t>
+            </a:r>
+            <a:endParaRPr lang="en-US" sz="1300" dirty="0"/>
+          </a:p>
+        </p:txBody>
+      </p:sp>
+      <p:sp>
+        <p:nvSpPr>
+          <p:cNvPr id="47" name="Shape 45">
+            <a:hlinkClick r:id="rId1" tooltip=""/>
           </p:cNvPr>
           <p:cNvSpPr/>
           <p:nvPr/>
         </p:nvSpPr>
         <p:spPr>
           <a:xfrm>
-            <a:off x="658368" y="6355080"/>
-            <a:ext cx="9921240" cy="219456"/>
-          </a:xfrm>
-          <a:prstGeom prst="rect">
-            <a:avLst/>
-          </a:prstGeom>
-          <a:noFill/>
-          <a:ln/>
-        </p:spPr>
-        <p:txBody>
-          <a:bodyPr wrap="square" lIns="0" tIns="0" rIns="0" bIns="0" rtlCol="0" anchor="ctr">
-            <a:normAutofit/>
-          </a:bodyPr>
-          <a:lstStyle/>
-          <a:p>
-            <a:pPr indent="0" marL="0">
-              <a:buNone/>
-            </a:pPr>
-            <a:r>
-              <a:rPr lang="en-US" sz="1000" u="sng" dirty="0">
-                <a:solidFill>
-                  <a:srgbClr val="728197"/>
-                </a:solidFill>
-                <a:latin typeface="Arial" pitchFamily="34" charset="0"/>
-                <a:ea typeface="Arial" pitchFamily="34" charset="-122"/>
-                <a:cs typeface="Arial" pitchFamily="34" charset="-120"/>
-                <a:hlinkClick r:id="rId4" invalidUrl="" action="" tgtFrame="" tooltip="" history="1" highlightClick="0" endSnd="0">
+            <a:off x="9454896" y="2240280"/>
+            <a:ext cx="1444752" cy="1444752"/>
+          </a:xfrm>
+          <a:prstGeom prst="ellipse">
+            <a:avLst/>
+          </a:prstGeom>
+          <a:solidFill>
+            <a:srgbClr val="F4B942"/>
+          </a:solidFill>
+          <a:ln w="50800">
+            <a:solidFill>
+              <a:srgbClr val="FFFFFF"/>
+            </a:solidFill>
+            <a:prstDash val="solid"/>
+          </a:ln>
+          <a:effectLst>
+            <a:outerShdw sx="100000" sy="100000" kx="0" ky="0" algn="bl" rotWithShape="0" blurRad="25400" dist="50800" dir="2700000">
+              <a:srgbClr val="0B1F33">
+                <a:alpha val="12000"/>
+              </a:srgbClr>
+            </a:outerShdw>
+          </a:effectLst>
+        </p:spPr>
+      </p:sp>
+      <p:sp>
+        <p:nvSpPr>
+          <p:cNvPr id="48" name="Shape 46">
+            <a:hlinkClick r:id="rId2" tooltip=""/>
+          </p:cNvPr>
+          <p:cNvSpPr/>
+          <p:nvPr/>
+        </p:nvSpPr>
+        <p:spPr>
+          <a:xfrm rot="5400000">
+            <a:off x="9948672" y="2660904"/>
+            <a:ext cx="512064" cy="640080"/>
+          </a:xfrm>
+          <a:prstGeom prst="triangle">
+            <a:avLst/>
+          </a:prstGeom>
+          <a:solidFill>
+            <a:srgbClr val="092F57"/>
+          </a:solidFill>
+          <a:ln w="12700">
+            <a:solidFill>
+              <a:srgbClr val="092F57">
+                <a:alpha val="0"/>
+              </a:srgbClr>
+            </a:solidFill>
+            <a:prstDash val="solid"/>
+          </a:ln>
+        </p:spPr>
+      </p:sp>
+      <p:sp>
+        <p:nvSpPr>
+          <p:cNvPr id="49" name="Text 47">
+            <a:hlinkClick r:id="rId3" tooltip=""/>
+          </p:cNvPr>
+          <p:cNvSpPr/>
+          <p:nvPr/>
+        </p:nvSpPr>
+        <p:spPr>
+          <a:xfrm>
+            <a:off x="9070848" y="3767328"/>
+            <a:ext cx="2231136" cy="228600"/>
+          </a:xfrm>
+          <a:prstGeom prst="rect">
+            <a:avLst/>
+          </a:prstGeom>
+          <a:noFill/>
+          <a:ln/>
+        </p:spPr>
+        <p:txBody>
+          <a:bodyPr wrap="square" lIns="0" tIns="0" rIns="0" bIns="0" rtlCol="0" anchor="ctr"/>
+          <a:lstStyle/>
+          <a:p>
+            <a:pPr algn="ctr" indent="0" marL="0">
+              <a:buNone/>
+            </a:pPr>
+            <a:r>
+              <a:rPr lang="en-US" sz="1250" b="1" u="sng" spc="70" kern="0" dirty="0">
+                <a:solidFill>
+                  <a:srgbClr val="FFFFFF"/>
+                </a:solidFill>
+                <a:hlinkClick r:id="rId3" invalidUrl="" action="" tgtFrame="" tooltip="" history="1" highlightClick="0" endSnd="0">
                   <a:extLst>
                     <a:ext uri="{A12FA001-AC4F-418D-AE19-62706E023703}">
                       <ahyp:hlinkClr xmlns:ahyp="http://schemas.microsoft.com/office/drawing/2018/hyperlinkcolor" val="tx"/>
@@ -12057,6 +11958,197 @@
                   </a:extLst>
                 </a:hlinkClick>
               </a:rPr>
+              <a:t>CLICK TO OPEN</a:t>
+            </a:r>
+            <a:endParaRPr lang="en-US" sz="1250" dirty="0"/>
+          </a:p>
+        </p:txBody>
+      </p:sp>
+      <p:sp>
+        <p:nvSpPr>
+          <p:cNvPr id="50" name="Shape 48">
+            <a:hlinkClick r:id="rId4" tooltip=""/>
+          </p:cNvPr>
+          <p:cNvSpPr/>
+          <p:nvPr/>
+        </p:nvSpPr>
+        <p:spPr>
+          <a:xfrm>
+            <a:off x="9189720" y="2176272"/>
+            <a:ext cx="1975104" cy="1901952"/>
+          </a:xfrm>
+          <a:prstGeom prst="rect">
+            <a:avLst/>
+          </a:prstGeom>
+          <a:solidFill>
+            <a:srgbClr val="FFFFFF">
+              <a:alpha val="0"/>
+            </a:srgbClr>
+          </a:solidFill>
+          <a:ln w="12700">
+            <a:solidFill>
+              <a:srgbClr val="FFFFFF">
+                <a:alpha val="0"/>
+              </a:srgbClr>
+            </a:solidFill>
+            <a:prstDash val="solid"/>
+          </a:ln>
+        </p:spPr>
+      </p:sp>
+      <p:sp>
+        <p:nvSpPr>
+          <p:cNvPr id="51" name="Shape 49"/>
+          <p:cNvSpPr/>
+          <p:nvPr/>
+        </p:nvSpPr>
+        <p:spPr>
+          <a:xfrm>
+            <a:off x="9162288" y="4069080"/>
+            <a:ext cx="2029968" cy="0"/>
+          </a:xfrm>
+          <a:prstGeom prst="line">
+            <a:avLst/>
+          </a:prstGeom>
+          <a:noFill/>
+          <a:ln w="12700">
+            <a:solidFill>
+              <a:srgbClr val="5D8194"/>
+            </a:solidFill>
+            <a:prstDash val="solid"/>
+          </a:ln>
+        </p:spPr>
+      </p:sp>
+      <p:sp>
+        <p:nvSpPr>
+          <p:cNvPr id="52" name="Text 50"/>
+          <p:cNvSpPr/>
+          <p:nvPr/>
+        </p:nvSpPr>
+        <p:spPr>
+          <a:xfrm>
+            <a:off x="9070848" y="4160520"/>
+            <a:ext cx="2231136" cy="164592"/>
+          </a:xfrm>
+          <a:prstGeom prst="rect">
+            <a:avLst/>
+          </a:prstGeom>
+          <a:noFill/>
+          <a:ln/>
+        </p:spPr>
+        <p:txBody>
+          <a:bodyPr wrap="square" lIns="0" tIns="0" rIns="0" bIns="0" rtlCol="0" anchor="ctr"/>
+          <a:lstStyle/>
+          <a:p>
+            <a:pPr algn="ctr" indent="0" marL="0">
+              <a:buNone/>
+            </a:pPr>
+            <a:r>
+              <a:rPr lang="en-US" sz="1050" b="1" spc="90" kern="0" dirty="0">
+                <a:solidFill>
+                  <a:srgbClr val="55D6BE"/>
+                </a:solidFill>
+              </a:rPr>
+              <a:t>OR SCAN</a:t>
+            </a:r>
+            <a:endParaRPr lang="en-US" sz="1050" dirty="0"/>
+          </a:p>
+        </p:txBody>
+      </p:sp>
+      <p:sp>
+        <p:nvSpPr>
+          <p:cNvPr id="53" name="Shape 51"/>
+          <p:cNvSpPr/>
+          <p:nvPr/>
+        </p:nvSpPr>
+        <p:spPr>
+          <a:xfrm>
+            <a:off x="9436608" y="4370832"/>
+            <a:ext cx="1481328" cy="1481328"/>
+          </a:xfrm>
+          <a:prstGeom prst="rect">
+            <a:avLst/>
+          </a:prstGeom>
+          <a:solidFill>
+            <a:srgbClr val="FFFFFF"/>
+          </a:solidFill>
+          <a:ln w="12700">
+            <a:solidFill>
+              <a:srgbClr val="FFFFFF"/>
+            </a:solidFill>
+            <a:prstDash val="solid"/>
+          </a:ln>
+        </p:spPr>
+      </p:sp>
+      <p:pic>
+        <p:nvPicPr>
+          <p:cNvPr id="54" name="Image 0" descr="QR code to the live AI Agent Job Redesign Coach">
+            <a:hlinkClick r:id="rId6" tooltip=""/>
+          </p:cNvPr>
+          <p:cNvPicPr>
+            <a:picLocks noChangeAspect="1"/>
+          </p:cNvPicPr>
+          <p:nvPr/>
+        </p:nvPicPr>
+        <p:blipFill>
+          <a:blip r:embed="rId5"/>
+          <a:stretch>
+            <a:fillRect/>
+          </a:stretch>
+        </p:blipFill>
+        <p:spPr>
+          <a:xfrm>
+            <a:off x="9500616" y="4434840"/>
+            <a:ext cx="1353312" cy="1353312"/>
+          </a:xfrm>
+          <a:prstGeom prst="rect">
+            <a:avLst/>
+          </a:prstGeom>
+        </p:spPr>
+      </p:pic>
+      <p:sp>
+        <p:nvSpPr>
+          <p:cNvPr id="55" name="Text 52">
+            <a:hlinkClick r:id="rId7" tooltip=""/>
+          </p:cNvPr>
+          <p:cNvSpPr/>
+          <p:nvPr/>
+        </p:nvSpPr>
+        <p:spPr>
+          <a:xfrm>
+            <a:off x="658368" y="6355080"/>
+            <a:ext cx="9921240" cy="219456"/>
+          </a:xfrm>
+          <a:prstGeom prst="rect">
+            <a:avLst/>
+          </a:prstGeom>
+          <a:noFill/>
+          <a:ln/>
+        </p:spPr>
+        <p:txBody>
+          <a:bodyPr wrap="square" lIns="0" tIns="0" rIns="0" bIns="0" rtlCol="0" anchor="ctr">
+            <a:normAutofit/>
+          </a:bodyPr>
+          <a:lstStyle/>
+          <a:p>
+            <a:pPr indent="0" marL="0">
+              <a:buNone/>
+            </a:pPr>
+            <a:r>
+              <a:rPr lang="en-US" sz="1000" u="sng" dirty="0">
+                <a:solidFill>
+                  <a:srgbClr val="728197"/>
+                </a:solidFill>
+                <a:latin typeface="Arial" pitchFamily="34" charset="0"/>
+                <a:ea typeface="Arial" pitchFamily="34" charset="-122"/>
+                <a:cs typeface="Arial" pitchFamily="34" charset="-120"/>
+                <a:hlinkClick r:id="rId7" invalidUrl="" action="" tgtFrame="" tooltip="" history="1" highlightClick="0" endSnd="0">
+                  <a:extLst>
+                    <a:ext uri="{A12FA001-AC4F-418D-AE19-62706E023703}">
+                      <ahyp:hlinkClr xmlns:ahyp="http://schemas.microsoft.com/office/drawing/2018/hyperlinkcolor" val="tx"/>
+                    </a:ext>
+                  </a:extLst>
+                </a:hlinkClick>
+              </a:rPr>
               <a:t>Live training simulator - six fictional scenarios; demo mode makes no external API calls</a:t>
             </a:r>
             <a:endParaRPr lang="en-US" sz="1000" dirty="0"/>
@@ -12065,7 +12157,7 @@
       </p:sp>
       <p:sp>
         <p:nvSpPr>
-          <p:cNvPr id="52" name="Text 49"/>
+          <p:cNvPr id="56" name="Text 53"/>
           <p:cNvSpPr/>
           <p:nvPr/>
         </p:nvSpPr>

</xml_diff>